<commit_message>
Updated slides for lecture 5.4
</commit_message>
<xml_diff>
--- a/Module 5/class_5.4/deep_learning_course_class_5.4.pptx
+++ b/Module 5/class_5.4/deep_learning_course_class_5.4.pptx
@@ -26,16 +26,18 @@
     <p:sldId id="271" r:id="rId22"/>
     <p:sldId id="272" r:id="rId23"/>
     <p:sldId id="273" r:id="rId24"/>
+    <p:sldId id="274" r:id="rId25"/>
+    <p:sldId id="275" r:id="rId26"/>
   </p:sldIdLst>
   <p:sldSz cy="5143500" cx="9144000"/>
   <p:notesSz cx="6858000" cy="9144000"/>
   <p:embeddedFontLst>
     <p:embeddedFont>
       <p:font typeface="Roboto"/>
-      <p:regular r:id="rId25"/>
-      <p:bold r:id="rId26"/>
-      <p:italic r:id="rId27"/>
-      <p:boldItalic r:id="rId28"/>
+      <p:regular r:id="rId27"/>
+      <p:bold r:id="rId28"/>
+      <p:italic r:id="rId29"/>
+      <p:boldItalic r:id="rId30"/>
     </p:embeddedFont>
   </p:embeddedFontLst>
   <p:defaultTextStyle>
@@ -1410,7 +1412,7 @@
   <p:cSld>
     <p:spTree>
       <p:nvGrpSpPr>
-        <p:cNvPr id="177" name="Shape 177"/>
+        <p:cNvPr id="178" name="Shape 178"/>
         <p:cNvGrpSpPr/>
         <p:nvPr/>
       </p:nvGrpSpPr>
@@ -1424,7 +1426,7 @@
       </p:grpSpPr>
       <p:sp>
         <p:nvSpPr>
-          <p:cNvPr id="178" name="Google Shape;178;g3ce00501541_0_19:notes"/>
+          <p:cNvPr id="179" name="Google Shape;179;g3ce00501541_0_19:notes"/>
           <p:cNvSpPr/>
           <p:nvPr>
             <p:ph idx="2" type="sldImg"/>
@@ -1459,7 +1461,7 @@
       </p:sp>
       <p:sp>
         <p:nvSpPr>
-          <p:cNvPr id="179" name="Google Shape;179;g3ce00501541_0_19:notes"/>
+          <p:cNvPr id="180" name="Google Shape;180;g3ce00501541_0_19:notes"/>
           <p:cNvSpPr txBox="1"/>
           <p:nvPr>
             <p:ph idx="1" type="body"/>
@@ -1509,7 +1511,7 @@
   <p:cSld>
     <p:spTree>
       <p:nvGrpSpPr>
-        <p:cNvPr id="185" name="Shape 185"/>
+        <p:cNvPr id="187" name="Shape 187"/>
         <p:cNvGrpSpPr/>
         <p:nvPr/>
       </p:nvGrpSpPr>
@@ -1523,7 +1525,7 @@
       </p:grpSpPr>
       <p:sp>
         <p:nvSpPr>
-          <p:cNvPr id="186" name="Google Shape;186;g395e0888514_0_42:notes"/>
+          <p:cNvPr id="188" name="Google Shape;188;g395e0888514_0_42:notes"/>
           <p:cNvSpPr/>
           <p:nvPr>
             <p:ph idx="2" type="sldImg"/>
@@ -1558,7 +1560,7 @@
       </p:sp>
       <p:sp>
         <p:nvSpPr>
-          <p:cNvPr id="187" name="Google Shape;187;g395e0888514_0_42:notes"/>
+          <p:cNvPr id="189" name="Google Shape;189;g395e0888514_0_42:notes"/>
           <p:cNvSpPr txBox="1"/>
           <p:nvPr>
             <p:ph idx="1" type="body"/>
@@ -1608,7 +1610,7 @@
   <p:cSld>
     <p:spTree>
       <p:nvGrpSpPr>
-        <p:cNvPr id="192" name="Shape 192"/>
+        <p:cNvPr id="194" name="Shape 194"/>
         <p:cNvGrpSpPr/>
         <p:nvPr/>
       </p:nvGrpSpPr>
@@ -1622,7 +1624,7 @@
       </p:grpSpPr>
       <p:sp>
         <p:nvSpPr>
-          <p:cNvPr id="193" name="Google Shape;193;g3ce00501541_0_28:notes"/>
+          <p:cNvPr id="195" name="Google Shape;195;g3cf40d67047_0_11:notes"/>
           <p:cNvSpPr/>
           <p:nvPr>
             <p:ph idx="2" type="sldImg"/>
@@ -1657,7 +1659,7 @@
       </p:sp>
       <p:sp>
         <p:nvSpPr>
-          <p:cNvPr id="194" name="Google Shape;194;g3ce00501541_0_28:notes"/>
+          <p:cNvPr id="196" name="Google Shape;196;g3cf40d67047_0_11:notes"/>
           <p:cNvSpPr txBox="1"/>
           <p:nvPr>
             <p:ph idx="1" type="body"/>
@@ -1702,12 +1704,12 @@
 </p:notes>
 </file>
 
-<file path=ppt/notesSlides/notesSlide2.xml><?xml version="1.0" encoding="utf-8"?>
+<file path=ppt/notesSlides/notesSlide19.xml><?xml version="1.0" encoding="utf-8"?>
 <p:notes xmlns:a="http://schemas.openxmlformats.org/drawingml/2006/main" xmlns:r="http://schemas.openxmlformats.org/officeDocument/2006/relationships" xmlns:mc="http://schemas.openxmlformats.org/markup-compatibility/2006" xmlns:mv="urn:schemas-microsoft-com:mac:vml" xmlns:p="http://schemas.openxmlformats.org/presentationml/2006/main" xmlns:c="http://schemas.openxmlformats.org/drawingml/2006/chart" xmlns:dgm="http://schemas.openxmlformats.org/drawingml/2006/diagram" xmlns:o="urn:schemas-microsoft-com:office:office" xmlns:v="urn:schemas-microsoft-com:vml" xmlns:pvml="urn:schemas-microsoft-com:office:powerpoint" xmlns:com="http://schemas.openxmlformats.org/drawingml/2006/compatibility" xmlns:p14="http://schemas.microsoft.com/office/powerpoint/2010/main" xmlns:p15="http://schemas.microsoft.com/office/powerpoint/2012/main" xmlns:ahyp="http://schemas.microsoft.com/office/drawing/2018/hyperlinkcolor" showMasterPhAnim="0" showMasterSp="0">
   <p:cSld>
     <p:spTree>
       <p:nvGrpSpPr>
-        <p:cNvPr id="56" name="Shape 56"/>
+        <p:cNvPr id="200" name="Shape 200"/>
         <p:cNvGrpSpPr/>
         <p:nvPr/>
       </p:nvGrpSpPr>
@@ -1721,7 +1723,7 @@
       </p:grpSpPr>
       <p:sp>
         <p:nvSpPr>
-          <p:cNvPr id="57" name="Google Shape;57;g3c887823e2c_0_5:notes"/>
+          <p:cNvPr id="201" name="Google Shape;201;g3ce00501541_0_28:notes"/>
           <p:cNvSpPr/>
           <p:nvPr>
             <p:ph idx="2" type="sldImg"/>
@@ -1756,7 +1758,7 @@
       </p:sp>
       <p:sp>
         <p:nvSpPr>
-          <p:cNvPr id="58" name="Google Shape;58;g3c887823e2c_0_5:notes"/>
+          <p:cNvPr id="202" name="Google Shape;202;g3ce00501541_0_28:notes"/>
           <p:cNvSpPr txBox="1"/>
           <p:nvPr>
             <p:ph idx="1" type="body"/>
@@ -1801,12 +1803,12 @@
 </p:notes>
 </file>
 
-<file path=ppt/notesSlides/notesSlide3.xml><?xml version="1.0" encoding="utf-8"?>
+<file path=ppt/notesSlides/notesSlide2.xml><?xml version="1.0" encoding="utf-8"?>
 <p:notes xmlns:a="http://schemas.openxmlformats.org/drawingml/2006/main" xmlns:r="http://schemas.openxmlformats.org/officeDocument/2006/relationships" xmlns:mc="http://schemas.openxmlformats.org/markup-compatibility/2006" xmlns:mv="urn:schemas-microsoft-com:mac:vml" xmlns:p="http://schemas.openxmlformats.org/presentationml/2006/main" xmlns:c="http://schemas.openxmlformats.org/drawingml/2006/chart" xmlns:dgm="http://schemas.openxmlformats.org/drawingml/2006/diagram" xmlns:o="urn:schemas-microsoft-com:office:office" xmlns:v="urn:schemas-microsoft-com:vml" xmlns:pvml="urn:schemas-microsoft-com:office:powerpoint" xmlns:com="http://schemas.openxmlformats.org/drawingml/2006/compatibility" xmlns:p14="http://schemas.microsoft.com/office/powerpoint/2010/main" xmlns:p15="http://schemas.microsoft.com/office/powerpoint/2012/main" xmlns:ahyp="http://schemas.microsoft.com/office/drawing/2018/hyperlinkcolor" showMasterPhAnim="0" showMasterSp="0">
   <p:cSld>
     <p:spTree>
       <p:nvGrpSpPr>
-        <p:cNvPr id="62" name="Shape 62"/>
+        <p:cNvPr id="56" name="Shape 56"/>
         <p:cNvGrpSpPr/>
         <p:nvPr/>
       </p:nvGrpSpPr>
@@ -1820,7 +1822,7 @@
       </p:grpSpPr>
       <p:sp>
         <p:nvSpPr>
-          <p:cNvPr id="63" name="Google Shape;63;g3c887823e2c_0_10:notes"/>
+          <p:cNvPr id="57" name="Google Shape;57;g3c887823e2c_0_10:notes"/>
           <p:cNvSpPr/>
           <p:nvPr>
             <p:ph idx="2" type="sldImg"/>
@@ -1855,7 +1857,7 @@
       </p:sp>
       <p:sp>
         <p:nvSpPr>
-          <p:cNvPr id="64" name="Google Shape;64;g3c887823e2c_0_10:notes"/>
+          <p:cNvPr id="58" name="Google Shape;58;g3c887823e2c_0_10:notes"/>
           <p:cNvSpPr txBox="1"/>
           <p:nvPr>
             <p:ph idx="1" type="body"/>
@@ -1900,12 +1902,12 @@
 </p:notes>
 </file>
 
-<file path=ppt/notesSlides/notesSlide4.xml><?xml version="1.0" encoding="utf-8"?>
+<file path=ppt/notesSlides/notesSlide20.xml><?xml version="1.0" encoding="utf-8"?>
 <p:notes xmlns:a="http://schemas.openxmlformats.org/drawingml/2006/main" xmlns:r="http://schemas.openxmlformats.org/officeDocument/2006/relationships" xmlns:mc="http://schemas.openxmlformats.org/markup-compatibility/2006" xmlns:mv="urn:schemas-microsoft-com:mac:vml" xmlns:p="http://schemas.openxmlformats.org/presentationml/2006/main" xmlns:c="http://schemas.openxmlformats.org/drawingml/2006/chart" xmlns:dgm="http://schemas.openxmlformats.org/drawingml/2006/diagram" xmlns:o="urn:schemas-microsoft-com:office:office" xmlns:v="urn:schemas-microsoft-com:vml" xmlns:pvml="urn:schemas-microsoft-com:office:powerpoint" xmlns:com="http://schemas.openxmlformats.org/drawingml/2006/compatibility" xmlns:p14="http://schemas.microsoft.com/office/powerpoint/2010/main" xmlns:p15="http://schemas.microsoft.com/office/powerpoint/2012/main" xmlns:ahyp="http://schemas.microsoft.com/office/drawing/2018/hyperlinkcolor" showMasterPhAnim="0" showMasterSp="0">
   <p:cSld>
     <p:spTree>
       <p:nvGrpSpPr>
-        <p:cNvPr id="68" name="Shape 68"/>
+        <p:cNvPr id="209" name="Shape 209"/>
         <p:cNvGrpSpPr/>
         <p:nvPr/>
       </p:nvGrpSpPr>
@@ -1919,7 +1921,7 @@
       </p:grpSpPr>
       <p:sp>
         <p:nvSpPr>
-          <p:cNvPr id="69" name="Google Shape;69;g3cc2793e28e_0_0:notes"/>
+          <p:cNvPr id="210" name="Google Shape;210;g3cf40d67047_0_17:notes"/>
           <p:cNvSpPr/>
           <p:nvPr>
             <p:ph idx="2" type="sldImg"/>
@@ -1954,7 +1956,7 @@
       </p:sp>
       <p:sp>
         <p:nvSpPr>
-          <p:cNvPr id="70" name="Google Shape;70;g3cc2793e28e_0_0:notes"/>
+          <p:cNvPr id="211" name="Google Shape;211;g3cf40d67047_0_17:notes"/>
           <p:cNvSpPr txBox="1"/>
           <p:nvPr>
             <p:ph idx="1" type="body"/>
@@ -1999,12 +2001,12 @@
 </p:notes>
 </file>
 
-<file path=ppt/notesSlides/notesSlide5.xml><?xml version="1.0" encoding="utf-8"?>
+<file path=ppt/notesSlides/notesSlide3.xml><?xml version="1.0" encoding="utf-8"?>
 <p:notes xmlns:a="http://schemas.openxmlformats.org/drawingml/2006/main" xmlns:r="http://schemas.openxmlformats.org/officeDocument/2006/relationships" xmlns:mc="http://schemas.openxmlformats.org/markup-compatibility/2006" xmlns:mv="urn:schemas-microsoft-com:mac:vml" xmlns:p="http://schemas.openxmlformats.org/presentationml/2006/main" xmlns:c="http://schemas.openxmlformats.org/drawingml/2006/chart" xmlns:dgm="http://schemas.openxmlformats.org/drawingml/2006/diagram" xmlns:o="urn:schemas-microsoft-com:office:office" xmlns:v="urn:schemas-microsoft-com:vml" xmlns:pvml="urn:schemas-microsoft-com:office:powerpoint" xmlns:com="http://schemas.openxmlformats.org/drawingml/2006/compatibility" xmlns:p14="http://schemas.microsoft.com/office/powerpoint/2010/main" xmlns:p15="http://schemas.microsoft.com/office/powerpoint/2012/main" xmlns:ahyp="http://schemas.microsoft.com/office/drawing/2018/hyperlinkcolor" showMasterPhAnim="0" showMasterSp="0">
   <p:cSld>
     <p:spTree>
       <p:nvGrpSpPr>
-        <p:cNvPr id="93" name="Shape 93"/>
+        <p:cNvPr id="62" name="Shape 62"/>
         <p:cNvGrpSpPr/>
         <p:nvPr/>
       </p:nvGrpSpPr>
@@ -2018,7 +2020,7 @@
       </p:grpSpPr>
       <p:sp>
         <p:nvSpPr>
-          <p:cNvPr id="94" name="Google Shape;94;g3c887823e2c_0_15:notes"/>
+          <p:cNvPr id="63" name="Google Shape;63;g3cc2793e28e_0_0:notes"/>
           <p:cNvSpPr/>
           <p:nvPr>
             <p:ph idx="2" type="sldImg"/>
@@ -2053,7 +2055,7 @@
       </p:sp>
       <p:sp>
         <p:nvSpPr>
-          <p:cNvPr id="95" name="Google Shape;95;g3c887823e2c_0_15:notes"/>
+          <p:cNvPr id="64" name="Google Shape;64;g3cc2793e28e_0_0:notes"/>
           <p:cNvSpPr txBox="1"/>
           <p:nvPr>
             <p:ph idx="1" type="body"/>
@@ -2098,12 +2100,12 @@
 </p:notes>
 </file>
 
-<file path=ppt/notesSlides/notesSlide6.xml><?xml version="1.0" encoding="utf-8"?>
+<file path=ppt/notesSlides/notesSlide4.xml><?xml version="1.0" encoding="utf-8"?>
 <p:notes xmlns:a="http://schemas.openxmlformats.org/drawingml/2006/main" xmlns:r="http://schemas.openxmlformats.org/officeDocument/2006/relationships" xmlns:mc="http://schemas.openxmlformats.org/markup-compatibility/2006" xmlns:mv="urn:schemas-microsoft-com:mac:vml" xmlns:p="http://schemas.openxmlformats.org/presentationml/2006/main" xmlns:c="http://schemas.openxmlformats.org/drawingml/2006/chart" xmlns:dgm="http://schemas.openxmlformats.org/drawingml/2006/diagram" xmlns:o="urn:schemas-microsoft-com:office:office" xmlns:v="urn:schemas-microsoft-com:vml" xmlns:pvml="urn:schemas-microsoft-com:office:powerpoint" xmlns:com="http://schemas.openxmlformats.org/drawingml/2006/compatibility" xmlns:p14="http://schemas.microsoft.com/office/powerpoint/2010/main" xmlns:p15="http://schemas.microsoft.com/office/powerpoint/2012/main" xmlns:ahyp="http://schemas.microsoft.com/office/drawing/2018/hyperlinkcolor" showMasterPhAnim="0" showMasterSp="0">
   <p:cSld>
     <p:spTree>
       <p:nvGrpSpPr>
-        <p:cNvPr id="99" name="Shape 99"/>
+        <p:cNvPr id="87" name="Shape 87"/>
         <p:cNvGrpSpPr/>
         <p:nvPr/>
       </p:nvGrpSpPr>
@@ -2117,7 +2119,7 @@
       </p:grpSpPr>
       <p:sp>
         <p:nvSpPr>
-          <p:cNvPr id="100" name="Google Shape;100;g3cc2793e28e_0_34:notes"/>
+          <p:cNvPr id="88" name="Google Shape;88;g3c887823e2c_0_15:notes"/>
           <p:cNvSpPr/>
           <p:nvPr>
             <p:ph idx="2" type="sldImg"/>
@@ -2152,7 +2154,7 @@
       </p:sp>
       <p:sp>
         <p:nvSpPr>
-          <p:cNvPr id="101" name="Google Shape;101;g3cc2793e28e_0_34:notes"/>
+          <p:cNvPr id="89" name="Google Shape;89;g3c887823e2c_0_15:notes"/>
           <p:cNvSpPr txBox="1"/>
           <p:nvPr>
             <p:ph idx="1" type="body"/>
@@ -2197,12 +2199,12 @@
 </p:notes>
 </file>
 
-<file path=ppt/notesSlides/notesSlide7.xml><?xml version="1.0" encoding="utf-8"?>
+<file path=ppt/notesSlides/notesSlide5.xml><?xml version="1.0" encoding="utf-8"?>
 <p:notes xmlns:a="http://schemas.openxmlformats.org/drawingml/2006/main" xmlns:r="http://schemas.openxmlformats.org/officeDocument/2006/relationships" xmlns:mc="http://schemas.openxmlformats.org/markup-compatibility/2006" xmlns:mv="urn:schemas-microsoft-com:mac:vml" xmlns:p="http://schemas.openxmlformats.org/presentationml/2006/main" xmlns:c="http://schemas.openxmlformats.org/drawingml/2006/chart" xmlns:dgm="http://schemas.openxmlformats.org/drawingml/2006/diagram" xmlns:o="urn:schemas-microsoft-com:office:office" xmlns:v="urn:schemas-microsoft-com:vml" xmlns:pvml="urn:schemas-microsoft-com:office:powerpoint" xmlns:com="http://schemas.openxmlformats.org/drawingml/2006/compatibility" xmlns:p14="http://schemas.microsoft.com/office/powerpoint/2010/main" xmlns:p15="http://schemas.microsoft.com/office/powerpoint/2012/main" xmlns:ahyp="http://schemas.microsoft.com/office/drawing/2018/hyperlinkcolor" showMasterPhAnim="0" showMasterSp="0">
   <p:cSld>
     <p:spTree>
       <p:nvGrpSpPr>
-        <p:cNvPr id="106" name="Shape 106"/>
+        <p:cNvPr id="93" name="Shape 93"/>
         <p:cNvGrpSpPr/>
         <p:nvPr/>
       </p:nvGrpSpPr>
@@ -2216,7 +2218,7 @@
       </p:grpSpPr>
       <p:sp>
         <p:nvSpPr>
-          <p:cNvPr id="107" name="Google Shape;107;g3c887823e2c_0_25:notes"/>
+          <p:cNvPr id="94" name="Google Shape;94;g3cc2793e28e_0_34:notes"/>
           <p:cNvSpPr/>
           <p:nvPr>
             <p:ph idx="2" type="sldImg"/>
@@ -2251,7 +2253,7 @@
       </p:sp>
       <p:sp>
         <p:nvSpPr>
-          <p:cNvPr id="108" name="Google Shape;108;g3c887823e2c_0_25:notes"/>
+          <p:cNvPr id="95" name="Google Shape;95;g3cc2793e28e_0_34:notes"/>
           <p:cNvSpPr txBox="1"/>
           <p:nvPr>
             <p:ph idx="1" type="body"/>
@@ -2296,12 +2298,12 @@
 </p:notes>
 </file>
 
-<file path=ppt/notesSlides/notesSlide8.xml><?xml version="1.0" encoding="utf-8"?>
+<file path=ppt/notesSlides/notesSlide6.xml><?xml version="1.0" encoding="utf-8"?>
 <p:notes xmlns:a="http://schemas.openxmlformats.org/drawingml/2006/main" xmlns:r="http://schemas.openxmlformats.org/officeDocument/2006/relationships" xmlns:mc="http://schemas.openxmlformats.org/markup-compatibility/2006" xmlns:mv="urn:schemas-microsoft-com:mac:vml" xmlns:p="http://schemas.openxmlformats.org/presentationml/2006/main" xmlns:c="http://schemas.openxmlformats.org/drawingml/2006/chart" xmlns:dgm="http://schemas.openxmlformats.org/drawingml/2006/diagram" xmlns:o="urn:schemas-microsoft-com:office:office" xmlns:v="urn:schemas-microsoft-com:vml" xmlns:pvml="urn:schemas-microsoft-com:office:powerpoint" xmlns:com="http://schemas.openxmlformats.org/drawingml/2006/compatibility" xmlns:p14="http://schemas.microsoft.com/office/powerpoint/2010/main" xmlns:p15="http://schemas.microsoft.com/office/powerpoint/2012/main" xmlns:ahyp="http://schemas.microsoft.com/office/drawing/2018/hyperlinkcolor" showMasterPhAnim="0" showMasterSp="0">
   <p:cSld>
     <p:spTree>
       <p:nvGrpSpPr>
-        <p:cNvPr id="113" name="Shape 113"/>
+        <p:cNvPr id="100" name="Shape 100"/>
         <p:cNvGrpSpPr/>
         <p:nvPr/>
       </p:nvGrpSpPr>
@@ -2315,7 +2317,7 @@
       </p:grpSpPr>
       <p:sp>
         <p:nvSpPr>
-          <p:cNvPr id="114" name="Google Shape;114;g3cc2793e28e_0_41:notes"/>
+          <p:cNvPr id="101" name="Google Shape;101;g3c887823e2c_0_25:notes"/>
           <p:cNvSpPr/>
           <p:nvPr>
             <p:ph idx="2" type="sldImg"/>
@@ -2350,7 +2352,205 @@
       </p:sp>
       <p:sp>
         <p:nvSpPr>
-          <p:cNvPr id="115" name="Google Shape;115;g3cc2793e28e_0_41:notes"/>
+          <p:cNvPr id="102" name="Google Shape;102;g3c887823e2c_0_25:notes"/>
+          <p:cNvSpPr txBox="1"/>
+          <p:nvPr>
+            <p:ph idx="1" type="body"/>
+          </p:nvPr>
+        </p:nvSpPr>
+        <p:spPr>
+          <a:xfrm>
+            <a:off x="685800" y="4343400"/>
+            <a:ext cx="5486400" cy="4114800"/>
+          </a:xfrm>
+          <a:prstGeom prst="rect">
+            <a:avLst/>
+          </a:prstGeom>
+        </p:spPr>
+        <p:txBody>
+          <a:bodyPr anchorCtr="0" anchor="t" bIns="91425" lIns="91425" spcFirstLastPara="1" rIns="91425" wrap="square" tIns="91425">
+            <a:noAutofit/>
+          </a:bodyPr>
+          <a:lstStyle/>
+          <a:p>
+            <a:pPr indent="0" lvl="0" marL="0" rtl="0" algn="l">
+              <a:spcBef>
+                <a:spcPts val="0"/>
+              </a:spcBef>
+              <a:spcAft>
+                <a:spcPts val="0"/>
+              </a:spcAft>
+              <a:buNone/>
+            </a:pPr>
+            <a:r>
+              <a:t/>
+            </a:r>
+            <a:endParaRPr/>
+          </a:p>
+        </p:txBody>
+      </p:sp>
+    </p:spTree>
+  </p:cSld>
+  <p:clrMapOvr>
+    <a:masterClrMapping/>
+  </p:clrMapOvr>
+</p:notes>
+</file>
+
+<file path=ppt/notesSlides/notesSlide7.xml><?xml version="1.0" encoding="utf-8"?>
+<p:notes xmlns:a="http://schemas.openxmlformats.org/drawingml/2006/main" xmlns:r="http://schemas.openxmlformats.org/officeDocument/2006/relationships" xmlns:mc="http://schemas.openxmlformats.org/markup-compatibility/2006" xmlns:mv="urn:schemas-microsoft-com:mac:vml" xmlns:p="http://schemas.openxmlformats.org/presentationml/2006/main" xmlns:c="http://schemas.openxmlformats.org/drawingml/2006/chart" xmlns:dgm="http://schemas.openxmlformats.org/drawingml/2006/diagram" xmlns:o="urn:schemas-microsoft-com:office:office" xmlns:v="urn:schemas-microsoft-com:vml" xmlns:pvml="urn:schemas-microsoft-com:office:powerpoint" xmlns:com="http://schemas.openxmlformats.org/drawingml/2006/compatibility" xmlns:p14="http://schemas.microsoft.com/office/powerpoint/2010/main" xmlns:p15="http://schemas.microsoft.com/office/powerpoint/2012/main" xmlns:ahyp="http://schemas.microsoft.com/office/drawing/2018/hyperlinkcolor" showMasterPhAnim="0" showMasterSp="0">
+  <p:cSld>
+    <p:spTree>
+      <p:nvGrpSpPr>
+        <p:cNvPr id="107" name="Shape 107"/>
+        <p:cNvGrpSpPr/>
+        <p:nvPr/>
+      </p:nvGrpSpPr>
+      <p:grpSpPr>
+        <a:xfrm>
+          <a:off x="0" y="0"/>
+          <a:ext cx="0" cy="0"/>
+          <a:chOff x="0" y="0"/>
+          <a:chExt cx="0" cy="0"/>
+        </a:xfrm>
+      </p:grpSpPr>
+      <p:sp>
+        <p:nvSpPr>
+          <p:cNvPr id="108" name="Google Shape;108;g3cc2793e28e_0_41:notes"/>
+          <p:cNvSpPr/>
+          <p:nvPr>
+            <p:ph idx="2" type="sldImg"/>
+          </p:nvPr>
+        </p:nvSpPr>
+        <p:spPr>
+          <a:xfrm>
+            <a:off x="381300" y="685800"/>
+            <a:ext cx="6096000" cy="3429000"/>
+          </a:xfrm>
+          <a:custGeom>
+            <a:rect b="b" l="l" r="r" t="t"/>
+            <a:pathLst>
+              <a:path extrusionOk="0" h="120000" w="120000">
+                <a:moveTo>
+                  <a:pt x="0" y="0"/>
+                </a:moveTo>
+                <a:lnTo>
+                  <a:pt x="120000" y="0"/>
+                </a:lnTo>
+                <a:lnTo>
+                  <a:pt x="120000" y="120000"/>
+                </a:lnTo>
+                <a:lnTo>
+                  <a:pt x="0" y="120000"/>
+                </a:lnTo>
+                <a:close/>
+              </a:path>
+            </a:pathLst>
+          </a:custGeom>
+        </p:spPr>
+      </p:sp>
+      <p:sp>
+        <p:nvSpPr>
+          <p:cNvPr id="109" name="Google Shape;109;g3cc2793e28e_0_41:notes"/>
+          <p:cNvSpPr txBox="1"/>
+          <p:nvPr>
+            <p:ph idx="1" type="body"/>
+          </p:nvPr>
+        </p:nvSpPr>
+        <p:spPr>
+          <a:xfrm>
+            <a:off x="685800" y="4343400"/>
+            <a:ext cx="5486400" cy="4114800"/>
+          </a:xfrm>
+          <a:prstGeom prst="rect">
+            <a:avLst/>
+          </a:prstGeom>
+        </p:spPr>
+        <p:txBody>
+          <a:bodyPr anchorCtr="0" anchor="t" bIns="91425" lIns="91425" spcFirstLastPara="1" rIns="91425" wrap="square" tIns="91425">
+            <a:noAutofit/>
+          </a:bodyPr>
+          <a:lstStyle/>
+          <a:p>
+            <a:pPr indent="0" lvl="0" marL="0" rtl="0" algn="l">
+              <a:spcBef>
+                <a:spcPts val="0"/>
+              </a:spcBef>
+              <a:spcAft>
+                <a:spcPts val="0"/>
+              </a:spcAft>
+              <a:buNone/>
+            </a:pPr>
+            <a:r>
+              <a:t/>
+            </a:r>
+            <a:endParaRPr/>
+          </a:p>
+        </p:txBody>
+      </p:sp>
+    </p:spTree>
+  </p:cSld>
+  <p:clrMapOvr>
+    <a:masterClrMapping/>
+  </p:clrMapOvr>
+</p:notes>
+</file>
+
+<file path=ppt/notesSlides/notesSlide8.xml><?xml version="1.0" encoding="utf-8"?>
+<p:notes xmlns:a="http://schemas.openxmlformats.org/drawingml/2006/main" xmlns:r="http://schemas.openxmlformats.org/officeDocument/2006/relationships" xmlns:mc="http://schemas.openxmlformats.org/markup-compatibility/2006" xmlns:mv="urn:schemas-microsoft-com:mac:vml" xmlns:p="http://schemas.openxmlformats.org/presentationml/2006/main" xmlns:c="http://schemas.openxmlformats.org/drawingml/2006/chart" xmlns:dgm="http://schemas.openxmlformats.org/drawingml/2006/diagram" xmlns:o="urn:schemas-microsoft-com:office:office" xmlns:v="urn:schemas-microsoft-com:vml" xmlns:pvml="urn:schemas-microsoft-com:office:powerpoint" xmlns:com="http://schemas.openxmlformats.org/drawingml/2006/compatibility" xmlns:p14="http://schemas.microsoft.com/office/powerpoint/2010/main" xmlns:p15="http://schemas.microsoft.com/office/powerpoint/2012/main" xmlns:ahyp="http://schemas.microsoft.com/office/drawing/2018/hyperlinkcolor" showMasterPhAnim="0" showMasterSp="0">
+  <p:cSld>
+    <p:spTree>
+      <p:nvGrpSpPr>
+        <p:cNvPr id="113" name="Shape 113"/>
+        <p:cNvGrpSpPr/>
+        <p:nvPr/>
+      </p:nvGrpSpPr>
+      <p:grpSpPr>
+        <a:xfrm>
+          <a:off x="0" y="0"/>
+          <a:ext cx="0" cy="0"/>
+          <a:chOff x="0" y="0"/>
+          <a:chExt cx="0" cy="0"/>
+        </a:xfrm>
+      </p:grpSpPr>
+      <p:sp>
+        <p:nvSpPr>
+          <p:cNvPr id="114" name="Google Shape;114;g3cf40d67047_0_0:notes"/>
+          <p:cNvSpPr/>
+          <p:nvPr>
+            <p:ph idx="2" type="sldImg"/>
+          </p:nvPr>
+        </p:nvSpPr>
+        <p:spPr>
+          <a:xfrm>
+            <a:off x="381300" y="685800"/>
+            <a:ext cx="6096000" cy="3429000"/>
+          </a:xfrm>
+          <a:custGeom>
+            <a:rect b="b" l="l" r="r" t="t"/>
+            <a:pathLst>
+              <a:path extrusionOk="0" h="120000" w="120000">
+                <a:moveTo>
+                  <a:pt x="0" y="0"/>
+                </a:moveTo>
+                <a:lnTo>
+                  <a:pt x="120000" y="0"/>
+                </a:lnTo>
+                <a:lnTo>
+                  <a:pt x="120000" y="120000"/>
+                </a:lnTo>
+                <a:lnTo>
+                  <a:pt x="0" y="120000"/>
+                </a:lnTo>
+                <a:close/>
+              </a:path>
+            </a:pathLst>
+          </a:custGeom>
+        </p:spPr>
+      </p:sp>
+      <p:sp>
+        <p:nvSpPr>
+          <p:cNvPr id="115" name="Google Shape;115;g3cf40d67047_0_0:notes"/>
           <p:cNvSpPr txBox="1"/>
           <p:nvPr>
             <p:ph idx="1" type="body"/>
@@ -7368,7 +7568,7 @@
             <a:tbl>
               <a:tblPr>
                 <a:noFill/>
-                <a:tableStyleId>{CC2E5028-35EF-4173-ACD8-1EDCF5F48ACF}</a:tableStyleId>
+                <a:tableStyleId>{089306F2-FB7C-4637-B24E-8EF8B1EACB90}</a:tableStyleId>
               </a:tblPr>
               <a:tblGrid>
                 <a:gridCol w="504925"/>
@@ -7681,7 +7881,7 @@
             <a:tbl>
               <a:tblPr>
                 <a:noFill/>
-                <a:tableStyleId>{CC2E5028-35EF-4173-ACD8-1EDCF5F48ACF}</a:tableStyleId>
+                <a:tableStyleId>{089306F2-FB7C-4637-B24E-8EF8B1EACB90}</a:tableStyleId>
               </a:tblPr>
               <a:tblGrid>
                 <a:gridCol w="504925"/>
@@ -7994,7 +8194,7 @@
             <a:tbl>
               <a:tblPr>
                 <a:noFill/>
-                <a:tableStyleId>{CC2E5028-35EF-4173-ACD8-1EDCF5F48ACF}</a:tableStyleId>
+                <a:tableStyleId>{089306F2-FB7C-4637-B24E-8EF8B1EACB90}</a:tableStyleId>
               </a:tblPr>
               <a:tblGrid>
                 <a:gridCol w="504925"/>
@@ -9034,7 +9234,7 @@
             <a:tbl>
               <a:tblPr>
                 <a:noFill/>
-                <a:tableStyleId>{CC2E5028-35EF-4173-ACD8-1EDCF5F48ACF}</a:tableStyleId>
+                <a:tableStyleId>{089306F2-FB7C-4637-B24E-8EF8B1EACB90}</a:tableStyleId>
               </a:tblPr>
               <a:tblGrid>
                 <a:gridCol w="382850"/>
@@ -9720,7 +9920,7 @@
             <a:tbl>
               <a:tblPr>
                 <a:noFill/>
-                <a:tableStyleId>{CC2E5028-35EF-4173-ACD8-1EDCF5F48ACF}</a:tableStyleId>
+                <a:tableStyleId>{089306F2-FB7C-4637-B24E-8EF8B1EACB90}</a:tableStyleId>
               </a:tblPr>
               <a:tblGrid>
                 <a:gridCol w="516750"/>
@@ -10678,7 +10878,8 @@
               <a:buNone/>
             </a:pPr>
             <a:r>
-              <a:t/>
+              <a:rPr lang="en"/>
+              <a:t>Self-Attention + Query Attention classifier: Results</a:t>
             </a:r>
             <a:endParaRPr/>
           </a:p>
@@ -10692,7 +10893,7 @@
         </p:nvSpPr>
         <p:spPr>
           <a:xfrm>
-            <a:off x="369350" y="1269725"/>
+            <a:off x="311700" y="1671400"/>
             <a:ext cx="6371700" cy="692700"/>
           </a:xfrm>
           <a:prstGeom prst="rect">
@@ -10766,8 +10967,8 @@
         </p:nvSpPr>
         <p:spPr>
           <a:xfrm>
-            <a:off x="311700" y="2770275"/>
-            <a:ext cx="8391600" cy="1416000"/>
+            <a:off x="406300" y="2733350"/>
+            <a:ext cx="8391600" cy="2432100"/>
           </a:xfrm>
           <a:prstGeom prst="rect">
             <a:avLst/>
@@ -10793,6 +10994,47 @@
               <a:buNone/>
             </a:pPr>
             <a:r>
+              <a:rPr lang="en" sz="1300"/>
+              <a:t>Inference Example:</a:t>
+            </a:r>
+            <a:endParaRPr sz="1300"/>
+          </a:p>
+          <a:p>
+            <a:pPr indent="0" lvl="0" marL="0" rtl="0" algn="l">
+              <a:spcBef>
+                <a:spcPts val="0"/>
+              </a:spcBef>
+              <a:spcAft>
+                <a:spcPts val="0"/>
+              </a:spcAft>
+              <a:buClr>
+                <a:schemeClr val="dk1"/>
+              </a:buClr>
+              <a:buSzPts val="1100"/>
+              <a:buFont typeface="Arial"/>
+              <a:buNone/>
+            </a:pPr>
+            <a:r>
+              <a:t/>
+            </a:r>
+            <a:endParaRPr sz="1300"/>
+          </a:p>
+          <a:p>
+            <a:pPr indent="0" lvl="0" marL="0" rtl="0" algn="l">
+              <a:spcBef>
+                <a:spcPts val="0"/>
+              </a:spcBef>
+              <a:spcAft>
+                <a:spcPts val="0"/>
+              </a:spcAft>
+              <a:buClr>
+                <a:schemeClr val="dk1"/>
+              </a:buClr>
+              <a:buSzPts val="1100"/>
+              <a:buFont typeface="Arial"/>
+              <a:buNone/>
+            </a:pPr>
+            <a:r>
               <a:rPr lang="en" sz="1000"/>
               <a:t> </a:t>
             </a:r>
@@ -10842,6 +11084,31 @@
               <a:spcAft>
                 <a:spcPts val="0"/>
               </a:spcAft>
+              <a:buClr>
+                <a:schemeClr val="dk1"/>
+              </a:buClr>
+              <a:buSzPts val="1100"/>
+              <a:buFont typeface="Arial"/>
+              <a:buNone/>
+            </a:pPr>
+            <a:r>
+              <a:t/>
+            </a:r>
+            <a:endParaRPr i="1" sz="1000"/>
+          </a:p>
+          <a:p>
+            <a:pPr indent="0" lvl="0" marL="0" rtl="0" algn="l">
+              <a:spcBef>
+                <a:spcPts val="0"/>
+              </a:spcBef>
+              <a:spcAft>
+                <a:spcPts val="0"/>
+              </a:spcAft>
+              <a:buClr>
+                <a:schemeClr val="dk1"/>
+              </a:buClr>
+              <a:buSzPts val="1100"/>
+              <a:buFont typeface="Arial"/>
               <a:buNone/>
             </a:pPr>
             <a:r>
@@ -10862,7 +11129,7 @@
             </a:pPr>
             <a:r>
               <a:rPr lang="en" sz="1000"/>
-              <a:t>food:0.01  the:0.12  food:0.03  was:0.04  bad:0.14  the:0.06  service:0.12  was:0.06  good:0.42</a:t>
+              <a:t>food:0.00  the:0.02  food:0.01  was:0.16  bad:0.07  the:0.02  service:0.02  was:0.26  good:0.44</a:t>
             </a:r>
             <a:endParaRPr sz="1000"/>
           </a:p>
@@ -10874,11 +11141,15 @@
               <a:spcAft>
                 <a:spcPts val="0"/>
               </a:spcAft>
+              <a:buClr>
+                <a:schemeClr val="dk1"/>
+              </a:buClr>
+              <a:buSzPts val="1100"/>
+              <a:buFont typeface="Arial"/>
               <a:buNone/>
             </a:pPr>
             <a:r>
-              <a:rPr lang="en" sz="1000"/>
-              <a:t> encoder self-attn ('bad' token attends to...):</a:t>
+              <a:t/>
             </a:r>
             <a:endParaRPr sz="1000"/>
           </a:p>
@@ -10890,11 +11161,16 @@
               <a:spcAft>
                 <a:spcPts val="0"/>
               </a:spcAft>
+              <a:buClr>
+                <a:schemeClr val="dk1"/>
+              </a:buClr>
+              <a:buSzPts val="1100"/>
+              <a:buFont typeface="Arial"/>
               <a:buNone/>
             </a:pPr>
             <a:r>
               <a:rPr lang="en" sz="1000"/>
-              <a:t>food:0.98  the:0.00  food:0.01  was:0.00  bad:0.00  the:0.00  service:0.00  was:0.00  good:0.00</a:t>
+              <a:t> encoder self-attn ('bad' token attends to...):</a:t>
             </a:r>
             <a:endParaRPr sz="1000"/>
           </a:p>
@@ -10910,7 +11186,7 @@
             </a:pPr>
             <a:r>
               <a:rPr lang="en" sz="1000"/>
-              <a:t> pooling attn (where we read out from):</a:t>
+              <a:t>food:0.91  the:0.01  food:0.06  was:0.00  bad:0.00  the:0.01  service:0.00  was:0.00  good:0.00</a:t>
             </a:r>
             <a:endParaRPr sz="1000"/>
           </a:p>
@@ -10922,13 +11198,124 @@
               <a:spcAft>
                 <a:spcPts val="0"/>
               </a:spcAft>
+              <a:buClr>
+                <a:schemeClr val="dk1"/>
+              </a:buClr>
+              <a:buSzPts val="1100"/>
+              <a:buFont typeface="Arial"/>
               <a:buNone/>
             </a:pPr>
             <a:r>
+              <a:t/>
+            </a:r>
+            <a:endParaRPr sz="1000"/>
+          </a:p>
+          <a:p>
+            <a:pPr indent="0" lvl="0" marL="0" rtl="0" algn="l">
+              <a:spcBef>
+                <a:spcPts val="0"/>
+              </a:spcBef>
+              <a:spcAft>
+                <a:spcPts val="0"/>
+              </a:spcAft>
+              <a:buClr>
+                <a:schemeClr val="dk1"/>
+              </a:buClr>
+              <a:buSzPts val="1100"/>
+              <a:buFont typeface="Arial"/>
+              <a:buNone/>
+            </a:pPr>
+            <a:r>
               <a:rPr lang="en" sz="1000"/>
-              <a:t>food:0.00  the:0.00  food:0.00  was:0.00  bad:1.00  the:0.00  service:0.00  was:0.00  good:0.00</a:t>
+              <a:t> pooling attn (where we read out from):</a:t>
             </a:r>
             <a:endParaRPr sz="1000"/>
+          </a:p>
+          <a:p>
+            <a:pPr indent="0" lvl="0" marL="0" rtl="0" algn="l">
+              <a:spcBef>
+                <a:spcPts val="0"/>
+              </a:spcBef>
+              <a:spcAft>
+                <a:spcPts val="0"/>
+              </a:spcAft>
+              <a:buClr>
+                <a:schemeClr val="dk1"/>
+              </a:buClr>
+              <a:buSzPts val="1100"/>
+              <a:buFont typeface="Arial"/>
+              <a:buNone/>
+            </a:pPr>
+            <a:r>
+              <a:rPr lang="en" sz="1000"/>
+              <a:t>food:0.00  the:0.00  food:0.00  was:0.00  bad:0.99  the:0.00  service:0.00  was:0.00  good:0.00</a:t>
+            </a:r>
+            <a:endParaRPr sz="1000"/>
+          </a:p>
+          <a:p>
+            <a:pPr indent="0" lvl="0" marL="0" rtl="0" algn="l">
+              <a:spcBef>
+                <a:spcPts val="0"/>
+              </a:spcBef>
+              <a:spcAft>
+                <a:spcPts val="0"/>
+              </a:spcAft>
+              <a:buNone/>
+            </a:pPr>
+            <a:r>
+              <a:t/>
+            </a:r>
+            <a:endParaRPr sz="1000"/>
+          </a:p>
+        </p:txBody>
+      </p:sp>
+      <p:sp>
+        <p:nvSpPr>
+          <p:cNvPr id="177" name="Google Shape;177;p27"/>
+          <p:cNvSpPr txBox="1"/>
+          <p:nvPr/>
+        </p:nvSpPr>
+        <p:spPr>
+          <a:xfrm>
+            <a:off x="406300" y="1237400"/>
+            <a:ext cx="4608000" cy="400200"/>
+          </a:xfrm>
+          <a:prstGeom prst="rect">
+            <a:avLst/>
+          </a:prstGeom>
+          <a:noFill/>
+          <a:ln>
+            <a:noFill/>
+          </a:ln>
+        </p:spPr>
+        <p:txBody>
+          <a:bodyPr anchorCtr="0" anchor="t" bIns="91425" lIns="91425" spcFirstLastPara="1" rIns="91425" wrap="square" tIns="91425">
+            <a:spAutoFit/>
+          </a:bodyPr>
+          <a:lstStyle/>
+          <a:p>
+            <a:pPr indent="0" lvl="0" marL="0" rtl="0" algn="l">
+              <a:spcBef>
+                <a:spcPts val="0"/>
+              </a:spcBef>
+              <a:spcAft>
+                <a:spcPts val="0"/>
+              </a:spcAft>
+              <a:buNone/>
+            </a:pPr>
+            <a:r>
+              <a:rPr lang="en">
+                <a:solidFill>
+                  <a:schemeClr val="dk2"/>
+                </a:solidFill>
+              </a:rPr>
+              <a:t>Classification accuracy on test data for a few epochs</a:t>
+            </a:r>
+            <a:endParaRPr>
+              <a:solidFill>
+                <a:schemeClr val="dk2"/>
+              </a:solidFill>
+            </a:endParaRPr>
           </a:p>
         </p:txBody>
       </p:sp>
@@ -10945,7 +11332,7 @@
   <p:cSld>
     <p:spTree>
       <p:nvGrpSpPr>
-        <p:cNvPr id="180" name="Shape 180"/>
+        <p:cNvPr id="181" name="Shape 181"/>
         <p:cNvGrpSpPr/>
         <p:nvPr/>
       </p:nvGrpSpPr>
@@ -10959,7 +11346,7 @@
       </p:grpSpPr>
       <p:sp>
         <p:nvSpPr>
-          <p:cNvPr id="181" name="Google Shape;181;p28"/>
+          <p:cNvPr id="182" name="Google Shape;182;p28"/>
           <p:cNvSpPr txBox="1"/>
           <p:nvPr>
             <p:ph type="title"/>
@@ -10999,7 +11386,7 @@
       </p:sp>
       <p:pic>
         <p:nvPicPr>
-          <p:cNvPr id="182" name="Google Shape;182;p28"/>
+          <p:cNvPr id="183" name="Google Shape;183;p28"/>
           <p:cNvPicPr preferRelativeResize="0"/>
           <p:nvPr/>
         </p:nvPicPr>
@@ -11013,36 +11400,8 @@
         </p:blipFill>
         <p:spPr>
           <a:xfrm>
-            <a:off x="3615225" y="2828000"/>
-            <a:ext cx="2936501" cy="2202376"/>
-          </a:xfrm>
-          <a:prstGeom prst="rect">
-            <a:avLst/>
-          </a:prstGeom>
-          <a:noFill/>
-          <a:ln>
-            <a:noFill/>
-          </a:ln>
-        </p:spPr>
-      </p:pic>
-      <p:pic>
-        <p:nvPicPr>
-          <p:cNvPr id="183" name="Google Shape;183;p28"/>
-          <p:cNvPicPr preferRelativeResize="0"/>
-          <p:nvPr/>
-        </p:nvPicPr>
-        <p:blipFill>
-          <a:blip r:embed="rId4">
-            <a:alphaModFix/>
-          </a:blip>
-          <a:stretch>
-            <a:fillRect/>
-          </a:stretch>
-        </p:blipFill>
-        <p:spPr>
-          <a:xfrm>
-            <a:off x="567900" y="2710250"/>
-            <a:ext cx="3185850" cy="2389375"/>
+            <a:off x="3442100" y="1108100"/>
+            <a:ext cx="2837226" cy="2127925"/>
           </a:xfrm>
           <a:prstGeom prst="rect">
             <a:avLst/>
@@ -11060,7 +11419,7 @@
           <p:nvPr/>
         </p:nvPicPr>
         <p:blipFill>
-          <a:blip r:embed="rId5">
+          <a:blip r:embed="rId4">
             <a:alphaModFix/>
           </a:blip>
           <a:stretch>
@@ -11069,8 +11428,8 @@
         </p:blipFill>
         <p:spPr>
           <a:xfrm>
-            <a:off x="4136975" y="877275"/>
-            <a:ext cx="3093450" cy="2320100"/>
+            <a:off x="392450" y="1108100"/>
+            <a:ext cx="3019626" cy="2264700"/>
           </a:xfrm>
           <a:prstGeom prst="rect">
             <a:avLst/>
@@ -11081,6 +11440,108 @@
           </a:ln>
         </p:spPr>
       </p:pic>
+      <p:pic>
+        <p:nvPicPr>
+          <p:cNvPr id="185" name="Google Shape;185;p28"/>
+          <p:cNvPicPr preferRelativeResize="0"/>
+          <p:nvPr/>
+        </p:nvPicPr>
+        <p:blipFill>
+          <a:blip r:embed="rId5">
+            <a:alphaModFix/>
+          </a:blip>
+          <a:stretch>
+            <a:fillRect/>
+          </a:stretch>
+        </p:blipFill>
+        <p:spPr>
+          <a:xfrm>
+            <a:off x="6153150" y="1054700"/>
+            <a:ext cx="2837226" cy="2127912"/>
+          </a:xfrm>
+          <a:prstGeom prst="rect">
+            <a:avLst/>
+          </a:prstGeom>
+          <a:noFill/>
+          <a:ln>
+            <a:noFill/>
+          </a:ln>
+        </p:spPr>
+      </p:pic>
+      <p:sp>
+        <p:nvSpPr>
+          <p:cNvPr id="186" name="Google Shape;186;p28"/>
+          <p:cNvSpPr txBox="1"/>
+          <p:nvPr/>
+        </p:nvSpPr>
+        <p:spPr>
+          <a:xfrm>
+            <a:off x="798775" y="3592150"/>
+            <a:ext cx="7405800" cy="1169700"/>
+          </a:xfrm>
+          <a:prstGeom prst="rect">
+            <a:avLst/>
+          </a:prstGeom>
+          <a:noFill/>
+          <a:ln>
+            <a:noFill/>
+          </a:ln>
+        </p:spPr>
+        <p:txBody>
+          <a:bodyPr anchorCtr="0" anchor="t" bIns="91425" lIns="91425" spcFirstLastPara="1" rIns="91425" wrap="square" tIns="91425">
+            <a:spAutoFit/>
+          </a:bodyPr>
+          <a:lstStyle/>
+          <a:p>
+            <a:pPr indent="0" lvl="0" marL="0" rtl="0" algn="l">
+              <a:spcBef>
+                <a:spcPts val="0"/>
+              </a:spcBef>
+              <a:spcAft>
+                <a:spcPts val="0"/>
+              </a:spcAft>
+              <a:buNone/>
+            </a:pPr>
+            <a:r>
+              <a:rPr lang="en" sz="1600">
+                <a:solidFill>
+                  <a:schemeClr val="dk2"/>
+                </a:solidFill>
+              </a:rPr>
+              <a:t>No visible change in the position embedding dot product heatmap, but the embeddings did change, with the movement higher for non-pad tokens.. </a:t>
+            </a:r>
+            <a:endParaRPr sz="1600">
+              <a:solidFill>
+                <a:schemeClr val="dk2"/>
+              </a:solidFill>
+            </a:endParaRPr>
+          </a:p>
+          <a:p>
+            <a:pPr indent="0" lvl="0" marL="0" rtl="0" algn="l">
+              <a:spcBef>
+                <a:spcPts val="0"/>
+              </a:spcBef>
+              <a:spcAft>
+                <a:spcPts val="0"/>
+              </a:spcAft>
+              <a:buNone/>
+            </a:pPr>
+            <a:r>
+              <a:rPr lang="en" sz="1600">
+                <a:solidFill>
+                  <a:schemeClr val="dk2"/>
+                </a:solidFill>
+              </a:rPr>
+              <a:t>The network learns just enough to do its job! No learning signal once accuracy reaches 100%..</a:t>
+            </a:r>
+            <a:endParaRPr sz="1600">
+              <a:solidFill>
+                <a:schemeClr val="dk2"/>
+              </a:solidFill>
+            </a:endParaRPr>
+          </a:p>
+        </p:txBody>
+      </p:sp>
     </p:spTree>
   </p:cSld>
   <p:clrMapOvr>
@@ -11094,7 +11555,7 @@
   <p:cSld>
     <p:spTree>
       <p:nvGrpSpPr>
-        <p:cNvPr id="188" name="Shape 188"/>
+        <p:cNvPr id="190" name="Shape 190"/>
         <p:cNvGrpSpPr/>
         <p:nvPr/>
       </p:nvGrpSpPr>
@@ -11108,7 +11569,7 @@
       </p:grpSpPr>
       <p:sp>
         <p:nvSpPr>
-          <p:cNvPr id="189" name="Google Shape;189;p29"/>
+          <p:cNvPr id="191" name="Google Shape;191;p29"/>
           <p:cNvSpPr txBox="1"/>
           <p:nvPr>
             <p:ph type="title"/>
@@ -11146,44 +11607,16 @@
           </a:p>
         </p:txBody>
       </p:sp>
-      <p:pic>
-        <p:nvPicPr>
-          <p:cNvPr descr="{&quot;font&quot;:{&quot;size&quot;:9.5,&quot;color&quot;:&quot;#000000&quot;,&quot;family&quot;:&quot;Arial&quot;},&quot;type&quot;:&quot;gather*&quot;,&quot;code&quot;:&quot;\\begin{gather*}\n{\\text{Input}\\;X:\\,T\\times D}\\\\\n{\\text{For}\\;\\text{head}\\;i\\in\\left\\{1,\\,2\\,\\dots,\\,h\\right\\}:}\\\\\n{W_{K}^{i},W_{Q}^{i}:\\,D\\times D_{k}}\\\\\n{W_{V}^{i}:D\\times D_{v}}\\\\\n{\\text{Compute}\\;\\text{each}\\;\\text{head}}\\\\\n{Q_{i}=XW_{Q}^{i}\\,\\to T\\times D_{k}}\\\\\n{K_{i}=XW_{K}^{i}\\,\\to T\\times D_{k}}\\\\\n{V_{i}=XW_{V}^{i}\\,\\to T\\times D_{v}}\\\\\n{A_{i}=Soft\\max\\left(\\frac{Q_{i}K_{i}^{T}}{{\\sqrt[]{D_{k}}}}\\right)\\to T\\times T}\\\\\n{H_{i}=A_{i}V_{i}\\to T\\times D_{v}}\\\\\n{\\text{Concatenate}\\;H_{i}\\,\\text{along}\\;\\text{the}\\;\\text{feature}\\;\\text{dimensions}}\\\\\n{H=concat\\left(H_{1},\\,H_{2}\\cdots H_{h}\\right)\\to T\\times hD_{v}}\\\\\n{\\text{Generally}\\;D_{v}\\,\\text{is}\\;\\text{chosen}\\;\\text{such}\\;\\text{that}\\;D_{v}h=D.\\,\\text{So}\\;\\text{the}\\;\\text{number}\\;\\text{of}\\;\\text{parameters}\\;\\text{in}\\;\\text{MHA}\\;\\text{is}\\;\\text{the}\\;\\text{same}\\;\\text{as}\\;\\text{single}\\;\\text{headed}\\;\\text{attention}}\t\n\\end{gather*}&quot;,&quot;aid&quot;:null,&quot;id&quot;:&quot;1&quot;,&quot;backgroundColor&quot;:&quot;#FFFFFF&quot;,&quot;backgroundColorModified&quot;:false,&quot;ts&quot;:1773016656004,&quot;cs&quot;:&quot;/tn/WgT7LMD4N0i3gCYtqQ==&quot;,&quot;size&quot;:{&quot;width&quot;:797.1495312335957,&quot;height&quot;:300.6719262467192}}" id="190" name="Google Shape;190;p29"/>
-          <p:cNvPicPr preferRelativeResize="0"/>
-          <p:nvPr/>
-        </p:nvPicPr>
-        <p:blipFill>
-          <a:blip r:embed="rId3">
-            <a:alphaModFix/>
-          </a:blip>
-          <a:stretch>
-            <a:fillRect/>
-          </a:stretch>
-        </p:blipFill>
-        <p:spPr>
-          <a:xfrm>
-            <a:off x="1351075" y="1389400"/>
-            <a:ext cx="7592849" cy="2863900"/>
-          </a:xfrm>
-          <a:prstGeom prst="rect">
-            <a:avLst/>
-          </a:prstGeom>
-          <a:noFill/>
-          <a:ln>
-            <a:noFill/>
-          </a:ln>
-        </p:spPr>
-      </p:pic>
       <p:sp>
         <p:nvSpPr>
-          <p:cNvPr id="191" name="Google Shape;191;p29"/>
+          <p:cNvPr id="192" name="Google Shape;192;p29"/>
           <p:cNvSpPr txBox="1"/>
           <p:nvPr/>
         </p:nvSpPr>
         <p:spPr>
           <a:xfrm>
-            <a:off x="265475" y="1337175"/>
-            <a:ext cx="3362700" cy="1108200"/>
+            <a:off x="403975" y="1017725"/>
+            <a:ext cx="7980600" cy="554100"/>
           </a:xfrm>
           <a:prstGeom prst="rect">
             <a:avLst/>
@@ -11238,6 +11671,34 @@
           </a:p>
         </p:txBody>
       </p:sp>
+      <p:pic>
+        <p:nvPicPr>
+          <p:cNvPr id="193" name="Google Shape;193;p29"/>
+          <p:cNvPicPr preferRelativeResize="0"/>
+          <p:nvPr/>
+        </p:nvPicPr>
+        <p:blipFill>
+          <a:blip r:embed="rId3">
+            <a:alphaModFix/>
+          </a:blip>
+          <a:stretch>
+            <a:fillRect/>
+          </a:stretch>
+        </p:blipFill>
+        <p:spPr>
+          <a:xfrm>
+            <a:off x="1602224" y="1571825"/>
+            <a:ext cx="5497174" cy="3592151"/>
+          </a:xfrm>
+          <a:prstGeom prst="rect">
+            <a:avLst/>
+          </a:prstGeom>
+          <a:noFill/>
+          <a:ln>
+            <a:noFill/>
+          </a:ln>
+        </p:spPr>
+      </p:pic>
     </p:spTree>
   </p:cSld>
   <p:clrMapOvr>
@@ -11251,7 +11712,7 @@
   <p:cSld>
     <p:spTree>
       <p:nvGrpSpPr>
-        <p:cNvPr id="195" name="Shape 195"/>
+        <p:cNvPr id="197" name="Shape 197"/>
         <p:cNvGrpSpPr/>
         <p:nvPr/>
       </p:nvGrpSpPr>
@@ -11265,7 +11726,7 @@
       </p:grpSpPr>
       <p:sp>
         <p:nvSpPr>
-          <p:cNvPr id="196" name="Google Shape;196;p30"/>
+          <p:cNvPr id="198" name="Google Shape;198;p30"/>
           <p:cNvSpPr txBox="1"/>
           <p:nvPr>
             <p:ph type="title"/>
@@ -11293,11 +11754,31 @@
               <a:spcAft>
                 <a:spcPts val="0"/>
               </a:spcAft>
+              <a:buClr>
+                <a:schemeClr val="dk1"/>
+              </a:buClr>
+              <a:buSzPct val="39285"/>
+              <a:buFont typeface="Arial"/>
               <a:buNone/>
             </a:pPr>
             <a:r>
               <a:rPr lang="en"/>
               <a:t>Multi-headed Attention</a:t>
+            </a:r>
+            <a:endParaRPr/>
+          </a:p>
+          <a:p>
+            <a:pPr indent="0" lvl="0" marL="0" rtl="0" algn="l">
+              <a:spcBef>
+                <a:spcPts val="0"/>
+              </a:spcBef>
+              <a:spcAft>
+                <a:spcPts val="0"/>
+              </a:spcAft>
+              <a:buNone/>
+            </a:pPr>
+            <a:r>
+              <a:t/>
             </a:r>
             <a:endParaRPr/>
           </a:p>
@@ -11305,7 +11786,100 @@
       </p:sp>
       <p:pic>
         <p:nvPicPr>
-          <p:cNvPr descr="{&quot;code&quot;:&quot;\\begin{gather*}\n{\\text{Implementations}\\;\\text{use}\\;\\text{a}\\;\\text{packed}\\;\\text{matrix,}\\;\\text{then}\\;\\text{reshape}\\;\\text{and}\\;\\text{split}.\\,\\text{This}\\;\\text{takes}\\;\\text{better}\\;\\text{advantage}\\;\\text{of}\\;\\text{parallel}\\;\\text{hardware}}\\\\\n{\\text{Input}\\;X:\\,T\\times D}\\\\\n{W_{K},W_{Q}:\\,D\\times hD_{k}}\\\\\n{W_{V}:D\\times hD_{v}}\\\\\n{\\text{Compute}\\;Q,\\,K,\\,V\\,\\text{projections}\\;\\text{(a}\\;\\text{single}\\;\\text{multiplication)}}\\\\\n{Q=XW_{Q}\\,\\to T\\times hD_{k}}\\\\\n{K=XW_{K}\\,\\to T\\times hD_{k}}\\\\\n{V=XW_{V}\\,\\to T\\times hD_{v}}\\\\\n{\\text{Reshape,}\\;\\text{transpose}}\\\\\n{T\\times hD_{k}\\to h\\times T\\times D_{k},\\,T\\times hD_{v}\\to h\\times T\\times D_{v}}\\\\\n{\\text{Per}\\;\\text{head}\\;\\text{attention}\\;\\text{scores}\\;\\text{(single}\\;\\text{matmul),}\\;\\text{transpos}\\text{e}\\;\\text{over}\\;\\text{last}\\;\\text{2}\\;\\text{dim}\\;\\text{(T,}\\;\\text{Dk}\\text{)}}\\\\\n{A=Soft\\max\\left(\\frac{QK^{T}}{{\\sqrt[]{D_{k}}}}\\right)\\to h\\times T\\times T}\\\\\n{\\text{Attention}\\;\\text{weighted}\\;\\text{sum}}\\\\\n{H=AV\\to h\\times T\\times D_{v}}\\\\\n{\\text{Transpose}\\;\\text{and}\\;\\text{reshape}}\\\\\n{h\\times T\\times D_{v}\\to T\\times h\\times D_{v}\\to T\\times hD_{v}}\t\n\\end{gather*}&quot;,&quot;aid&quot;:null,&quot;backgroundColor&quot;:&quot;#FFFFFF&quot;,&quot;font&quot;:{&quot;size&quot;:9.5,&quot;family&quot;:&quot;Arial&quot;,&quot;color&quot;:&quot;#000000&quot;},&quot;backgroundColorModified&quot;:false,&quot;type&quot;:&quot;gather*&quot;,&quot;id&quot;:&quot;1&quot;,&quot;ts&quot;:1773059249285,&quot;cs&quot;:&quot;asQllyFpuDyptHnBFqOd6A==&quot;,&quot;size&quot;:{&quot;width&quot;:714,&quot;height&quot;:327}}" id="197" name="Google Shape;197;p30"/>
+          <p:cNvPr descr="{&quot;font&quot;:{&quot;size&quot;:9.5,&quot;color&quot;:&quot;#000000&quot;,&quot;family&quot;:&quot;Arial&quot;},&quot;type&quot;:&quot;gather*&quot;,&quot;code&quot;:&quot;\\begin{gather*}\n{\\text{Input}\\;X:\\,T\\times D}\\\\\n{\\text{For}\\;\\text{head}\\;i\\in\\left\\{1,\\,2\\,\\dots,\\,h\\right\\}:}\\\\\n{W_{K}^{i},W_{Q}^{i}:\\,D\\times D_{k}}\\\\\n{W_{V}^{i}:D\\times D_{v}}\\\\\n{\\text{Compute}\\;\\text{each}\\;\\text{head}}\\\\\n{Q_{i}=XW_{Q}^{i}\\,\\to T\\times D_{k}}\\\\\n{K_{i}=XW_{K}^{i}\\,\\to T\\times D_{k}}\\\\\n{V_{i}=XW_{V}^{i}\\,\\to T\\times D_{v}}\\\\\n{A_{i}=Soft\\max\\left(\\frac{Q_{i}K_{i}^{T}}{{\\sqrt[]{D_{k}}}}\\right)\\to T\\times T}\\\\\n{H_{i}=A_{i}V_{i}\\to T\\times D_{v}}\\\\\n{\\text{Concatenate}\\;H_{i}\\,\\text{along}\\;\\text{the}\\;\\text{feature}\\;\\text{dimensions}}\\\\\n{H=concat\\left(H_{1},\\,H_{2}\\cdots H_{h}\\right)\\to T\\times hD_{v}}\\\\\n{\\text{Generally}\\;D_{v}\\,\\text{is}\\;\\text{chosen}\\;\\text{such}\\;\\text{that}\\;D_{v}h=D.\\,\\text{So}\\;\\text{the}\\;\\text{number}\\;\\text{of}\\;\\text{parameters}\\;\\text{in}\\;\\text{MHA}\\;\\text{is}\\;\\text{the}\\;\\text{same}\\;\\text{as}\\;\\text{single}\\;\\text{headed}\\;\\text{attention}}\t\n\\end{gather*}&quot;,&quot;aid&quot;:null,&quot;id&quot;:&quot;1&quot;,&quot;backgroundColor&quot;:&quot;#FFFFFF&quot;,&quot;backgroundColorModified&quot;:false,&quot;ts&quot;:1773016656004,&quot;cs&quot;:&quot;/tn/WgT7LMD4N0i3gCYtqQ==&quot;,&quot;size&quot;:{&quot;width&quot;:797.1495312335957,&quot;height&quot;:300.6719262467192}}" id="199" name="Google Shape;199;p30"/>
+          <p:cNvPicPr preferRelativeResize="0"/>
+          <p:nvPr/>
+        </p:nvPicPr>
+        <p:blipFill>
+          <a:blip r:embed="rId3">
+            <a:alphaModFix/>
+          </a:blip>
+          <a:stretch>
+            <a:fillRect/>
+          </a:stretch>
+        </p:blipFill>
+        <p:spPr>
+          <a:xfrm>
+            <a:off x="521100" y="1389400"/>
+            <a:ext cx="8422826" cy="3176950"/>
+          </a:xfrm>
+          <a:prstGeom prst="rect">
+            <a:avLst/>
+          </a:prstGeom>
+          <a:noFill/>
+          <a:ln>
+            <a:noFill/>
+          </a:ln>
+        </p:spPr>
+      </p:pic>
+    </p:spTree>
+  </p:cSld>
+  <p:clrMapOvr>
+    <a:masterClrMapping/>
+  </p:clrMapOvr>
+</p:sld>
+</file>
+
+<file path=ppt/slides/slide19.xml><?xml version="1.0" encoding="utf-8"?>
+<p:sld xmlns:a="http://schemas.openxmlformats.org/drawingml/2006/main" xmlns:r="http://schemas.openxmlformats.org/officeDocument/2006/relationships" xmlns:mc="http://schemas.openxmlformats.org/markup-compatibility/2006" xmlns:mv="urn:schemas-microsoft-com:mac:vml" xmlns:p="http://schemas.openxmlformats.org/presentationml/2006/main" xmlns:c="http://schemas.openxmlformats.org/drawingml/2006/chart" xmlns:dgm="http://schemas.openxmlformats.org/drawingml/2006/diagram" xmlns:o="urn:schemas-microsoft-com:office:office" xmlns:v="urn:schemas-microsoft-com:vml" xmlns:pvml="urn:schemas-microsoft-com:office:powerpoint" xmlns:com="http://schemas.openxmlformats.org/drawingml/2006/compatibility" xmlns:p14="http://schemas.microsoft.com/office/powerpoint/2010/main" xmlns:p15="http://schemas.microsoft.com/office/powerpoint/2012/main" xmlns:ahyp="http://schemas.microsoft.com/office/drawing/2018/hyperlinkcolor">
+  <p:cSld>
+    <p:spTree>
+      <p:nvGrpSpPr>
+        <p:cNvPr id="203" name="Shape 203"/>
+        <p:cNvGrpSpPr/>
+        <p:nvPr/>
+      </p:nvGrpSpPr>
+      <p:grpSpPr>
+        <a:xfrm>
+          <a:off x="0" y="0"/>
+          <a:ext cx="0" cy="0"/>
+          <a:chOff x="0" y="0"/>
+          <a:chExt cx="0" cy="0"/>
+        </a:xfrm>
+      </p:grpSpPr>
+      <p:sp>
+        <p:nvSpPr>
+          <p:cNvPr id="204" name="Google Shape;204;p31"/>
+          <p:cNvSpPr txBox="1"/>
+          <p:nvPr>
+            <p:ph type="title"/>
+          </p:nvPr>
+        </p:nvSpPr>
+        <p:spPr>
+          <a:xfrm>
+            <a:off x="311700" y="445025"/>
+            <a:ext cx="8520600" cy="572700"/>
+          </a:xfrm>
+          <a:prstGeom prst="rect">
+            <a:avLst/>
+          </a:prstGeom>
+        </p:spPr>
+        <p:txBody>
+          <a:bodyPr anchorCtr="0" anchor="t" bIns="91425" lIns="91425" spcFirstLastPara="1" rIns="91425" wrap="square" tIns="91425">
+            <a:normAutofit fontScale="90000"/>
+          </a:bodyPr>
+          <a:lstStyle/>
+          <a:p>
+            <a:pPr indent="0" lvl="0" marL="0" rtl="0" algn="l">
+              <a:spcBef>
+                <a:spcPts val="0"/>
+              </a:spcBef>
+              <a:spcAft>
+                <a:spcPts val="0"/>
+              </a:spcAft>
+              <a:buNone/>
+            </a:pPr>
+            <a:r>
+              <a:rPr lang="en"/>
+              <a:t>Multi-headed Attention</a:t>
+            </a:r>
+            <a:endParaRPr/>
+          </a:p>
+        </p:txBody>
+      </p:sp>
+      <p:pic>
+        <p:nvPicPr>
+          <p:cNvPr descr="{&quot;code&quot;:&quot;\\begin{gather*}\n{\\text{Implementations}\\;\\text{use}\\;\\text{a}\\;\\text{packed}\\;\\text{matrix,}\\;\\text{then}\\;\\text{reshape}\\;\\text{and}\\;\\text{split}.\\,\\text{This}\\;\\text{takes}\\;\\text{better}\\;\\text{advantage}\\;\\text{of}\\;\\text{parallel}\\;\\text{hardware}}\\\\\n{\\text{Input}\\;X:\\,T\\times D}\\\\\n{W_{K},W_{Q}:\\,D\\times hD_{k}}\\\\\n{W_{V}:D\\times hD_{v}}\\\\\n{\\text{Compute}\\;Q,\\,K,\\,V\\,\\text{projections}\\;\\text{(a}\\;\\text{single}\\;\\text{multiplication)}}\\\\\n{Q=XW_{Q}\\,\\to T\\times hD_{k}}\\\\\n{K=XW_{K}\\,\\to T\\times hD_{k}}\\\\\n{V=XW_{V}\\,\\to T\\times hD_{v}}\\\\\n{\\text{Reshape,}\\;\\text{transpose}}\\\\\n{T\\times hD_{k}\\to h\\times T\\times D_{k},\\,T\\times hD_{v}\\to h\\times T\\times D_{v}}\\\\\n{\\text{Per}\\;\\text{head}\\;\\text{attention}\\;\\text{scores}\\;\\text{(single}\\;\\text{matmul),}\\;\\text{transpos}\\text{e}\\;\\text{over}\\;\\text{last}\\;\\text{2}\\;\\text{dim}\\;\\text{(T,}\\;\\text{Dk}\\text{)}}\\\\\n{A=Soft\\max\\left(\\frac{QK^{T}}{{\\sqrt[]{D_{k}}}}\\right)\\to h\\times T\\times T}\\\\\n{\\text{Attention}\\;\\text{weighted}\\;\\text{sum}}\\\\\n{H=AV\\to h\\times T\\times D_{v}}\\\\\n{\\text{Transpose}\\;\\text{and}\\;\\text{reshape}}\\\\\n{h\\times T\\times D_{v}\\to T\\times h\\times D_{v}\\to T\\times hD_{v}}\t\n\\end{gather*}&quot;,&quot;aid&quot;:null,&quot;backgroundColor&quot;:&quot;#FFFFFF&quot;,&quot;font&quot;:{&quot;size&quot;:9.5,&quot;family&quot;:&quot;Arial&quot;,&quot;color&quot;:&quot;#000000&quot;},&quot;backgroundColorModified&quot;:false,&quot;type&quot;:&quot;gather*&quot;,&quot;id&quot;:&quot;1&quot;,&quot;ts&quot;:1773059249285,&quot;cs&quot;:&quot;asQllyFpuDyptHnBFqOd6A==&quot;,&quot;size&quot;:{&quot;width&quot;:714,&quot;height&quot;:327}}" id="205" name="Google Shape;205;p31"/>
           <p:cNvPicPr preferRelativeResize="0"/>
           <p:nvPr/>
         </p:nvPicPr>
@@ -11333,7 +11907,7 @@
       </p:pic>
       <p:sp>
         <p:nvSpPr>
-          <p:cNvPr id="198" name="Google Shape;198;p30"/>
+          <p:cNvPr id="206" name="Google Shape;206;p31"/>
           <p:cNvSpPr txBox="1"/>
           <p:nvPr/>
         </p:nvSpPr>
@@ -11383,7 +11957,7 @@
       </p:sp>
       <p:sp>
         <p:nvSpPr>
-          <p:cNvPr id="199" name="Google Shape;199;p30"/>
+          <p:cNvPr id="207" name="Google Shape;207;p31"/>
           <p:cNvSpPr txBox="1"/>
           <p:nvPr/>
         </p:nvSpPr>
@@ -11457,7 +12031,7 @@
       </p:sp>
       <p:cxnSp>
         <p:nvCxnSpPr>
-          <p:cNvPr id="200" name="Google Shape;200;p30"/>
+          <p:cNvPr id="208" name="Google Shape;208;p31"/>
           <p:cNvCxnSpPr/>
           <p:nvPr/>
         </p:nvCxnSpPr>
@@ -11540,7 +12114,7 @@
             </a:pPr>
             <a:r>
               <a:rPr lang="en"/>
-              <a:t>Text</a:t>
+              <a:t>Transformers: Main idea</a:t>
             </a:r>
             <a:endParaRPr/>
           </a:p>
@@ -11579,56 +12153,252 @@
               <a:buNone/>
             </a:pPr>
             <a:r>
+              <a:rPr lang="en" sz="1200"/>
+              <a:t>How do I represent a sentence as a fixed length embedding?</a:t>
+            </a:r>
+            <a:endParaRPr sz="1200"/>
+          </a:p>
+          <a:p>
+            <a:pPr indent="0" lvl="0" marL="0" rtl="0" algn="l">
+              <a:spcBef>
+                <a:spcPts val="1200"/>
+              </a:spcBef>
+              <a:spcAft>
+                <a:spcPts val="0"/>
+              </a:spcAft>
+              <a:buNone/>
+            </a:pPr>
+            <a:r>
+              <a:rPr lang="en" sz="1200"/>
+              <a:t>Could</a:t>
+            </a:r>
+            <a:r>
+              <a:rPr lang="en" sz="1200"/>
+              <a:t> take avg/max of each embedding dimension across tokens..</a:t>
+            </a:r>
+            <a:endParaRPr sz="1200"/>
+          </a:p>
+          <a:p>
+            <a:pPr indent="0" lvl="0" marL="0" rtl="0" algn="l">
+              <a:spcBef>
+                <a:spcPts val="1200"/>
+              </a:spcBef>
+              <a:spcAft>
+                <a:spcPts val="0"/>
+              </a:spcAft>
+              <a:buNone/>
+            </a:pPr>
+            <a:r>
+              <a:rPr lang="en" sz="1200"/>
+              <a:t>But this gives equal weight to each token.. When the importance of each token depends on the question you are trying to answer</a:t>
+            </a:r>
+            <a:endParaRPr sz="1200"/>
+          </a:p>
+          <a:p>
+            <a:pPr indent="0" lvl="0" marL="0" rtl="0" algn="l">
+              <a:spcBef>
+                <a:spcPts val="1200"/>
+              </a:spcBef>
+              <a:spcAft>
+                <a:spcPts val="0"/>
+              </a:spcAft>
+              <a:buNone/>
+            </a:pPr>
+            <a:r>
+              <a:rPr lang="en" sz="1200"/>
+              <a:t>Eg., “The food was great but the service was terrible”</a:t>
+            </a:r>
+            <a:endParaRPr sz="1200"/>
+          </a:p>
+          <a:p>
+            <a:pPr indent="0" lvl="0" marL="0" rtl="0" algn="l">
+              <a:spcBef>
+                <a:spcPts val="1200"/>
+              </a:spcBef>
+              <a:spcAft>
+                <a:spcPts val="0"/>
+              </a:spcAft>
+              <a:buNone/>
+            </a:pPr>
+            <a:r>
+              <a:rPr lang="en" sz="1200"/>
+              <a:t>Question: How was the food? Need to understand attribute “great” is bound to food</a:t>
+            </a:r>
+            <a:endParaRPr sz="1200"/>
+          </a:p>
+          <a:p>
+            <a:pPr indent="0" lvl="0" marL="0" rtl="0" algn="l">
+              <a:spcBef>
+                <a:spcPts val="1200"/>
+              </a:spcBef>
+              <a:spcAft>
+                <a:spcPts val="0"/>
+              </a:spcAft>
+              <a:buNone/>
+            </a:pPr>
+            <a:r>
+              <a:rPr lang="en" sz="1200"/>
+              <a:t>Question: How was the service? </a:t>
+            </a:r>
+            <a:r>
+              <a:rPr lang="en" sz="1200"/>
+              <a:t>Need to understand attribute “terrible” is bound to service</a:t>
+            </a:r>
+            <a:endParaRPr sz="1200"/>
+          </a:p>
+          <a:p>
+            <a:pPr indent="0" lvl="0" marL="0" rtl="0" algn="l">
+              <a:spcBef>
+                <a:spcPts val="1200"/>
+              </a:spcBef>
+              <a:spcAft>
+                <a:spcPts val="1200"/>
+              </a:spcAft>
+              <a:buNone/>
+            </a:pPr>
+            <a:r>
+              <a:rPr lang="en" sz="1200"/>
+              <a:t>A flat embedding representation that collapses the token embeddings into a single embedding vector would fail at this task</a:t>
+            </a:r>
+            <a:endParaRPr sz="1200"/>
+          </a:p>
+        </p:txBody>
+      </p:sp>
+    </p:spTree>
+  </p:cSld>
+  <p:clrMapOvr>
+    <a:masterClrMapping/>
+  </p:clrMapOvr>
+</p:sld>
+</file>
+
+<file path=ppt/slides/slide20.xml><?xml version="1.0" encoding="utf-8"?>
+<p:sld xmlns:a="http://schemas.openxmlformats.org/drawingml/2006/main" xmlns:r="http://schemas.openxmlformats.org/officeDocument/2006/relationships" xmlns:mc="http://schemas.openxmlformats.org/markup-compatibility/2006" xmlns:mv="urn:schemas-microsoft-com:mac:vml" xmlns:p="http://schemas.openxmlformats.org/presentationml/2006/main" xmlns:c="http://schemas.openxmlformats.org/drawingml/2006/chart" xmlns:dgm="http://schemas.openxmlformats.org/drawingml/2006/diagram" xmlns:o="urn:schemas-microsoft-com:office:office" xmlns:v="urn:schemas-microsoft-com:vml" xmlns:pvml="urn:schemas-microsoft-com:office:powerpoint" xmlns:com="http://schemas.openxmlformats.org/drawingml/2006/compatibility" xmlns:p14="http://schemas.microsoft.com/office/powerpoint/2010/main" xmlns:p15="http://schemas.microsoft.com/office/powerpoint/2012/main" xmlns:ahyp="http://schemas.microsoft.com/office/drawing/2018/hyperlinkcolor">
+  <p:cSld>
+    <p:spTree>
+      <p:nvGrpSpPr>
+        <p:cNvPr id="212" name="Shape 212"/>
+        <p:cNvGrpSpPr/>
+        <p:nvPr/>
+      </p:nvGrpSpPr>
+      <p:grpSpPr>
+        <a:xfrm>
+          <a:off x="0" y="0"/>
+          <a:ext cx="0" cy="0"/>
+          <a:chOff x="0" y="0"/>
+          <a:chExt cx="0" cy="0"/>
+        </a:xfrm>
+      </p:grpSpPr>
+      <p:sp>
+        <p:nvSpPr>
+          <p:cNvPr id="213" name="Google Shape;213;p32"/>
+          <p:cNvSpPr txBox="1"/>
+          <p:nvPr>
+            <p:ph type="title"/>
+          </p:nvPr>
+        </p:nvSpPr>
+        <p:spPr>
+          <a:xfrm>
+            <a:off x="311700" y="445025"/>
+            <a:ext cx="8520600" cy="572700"/>
+          </a:xfrm>
+          <a:prstGeom prst="rect">
+            <a:avLst/>
+          </a:prstGeom>
+        </p:spPr>
+        <p:txBody>
+          <a:bodyPr anchorCtr="0" anchor="t" bIns="91425" lIns="91425" spcFirstLastPara="1" rIns="91425" wrap="square" tIns="91425">
+            <a:normAutofit fontScale="90000"/>
+          </a:bodyPr>
+          <a:lstStyle/>
+          <a:p>
+            <a:pPr indent="0" lvl="0" marL="0" rtl="0" algn="l">
+              <a:spcBef>
+                <a:spcPts val="0"/>
+              </a:spcBef>
+              <a:spcAft>
+                <a:spcPts val="0"/>
+              </a:spcAft>
+              <a:buNone/>
+            </a:pPr>
+            <a:r>
               <a:rPr lang="en"/>
-              <a:t>We’ll motivate transformers through text</a:t>
+              <a:t>What’s next..</a:t>
+            </a:r>
+            <a:endParaRPr/>
+          </a:p>
+        </p:txBody>
+      </p:sp>
+      <p:sp>
+        <p:nvSpPr>
+          <p:cNvPr id="214" name="Google Shape;214;p32"/>
+          <p:cNvSpPr txBox="1"/>
+          <p:nvPr>
+            <p:ph idx="1" type="body"/>
+          </p:nvPr>
+        </p:nvSpPr>
+        <p:spPr>
+          <a:xfrm>
+            <a:off x="311700" y="1152475"/>
+            <a:ext cx="8520600" cy="3416400"/>
+          </a:xfrm>
+          <a:prstGeom prst="rect">
+            <a:avLst/>
+          </a:prstGeom>
+        </p:spPr>
+        <p:txBody>
+          <a:bodyPr anchorCtr="0" anchor="t" bIns="91425" lIns="91425" spcFirstLastPara="1" rIns="91425" wrap="square" tIns="91425">
+            <a:normAutofit/>
+          </a:bodyPr>
+          <a:lstStyle/>
+          <a:p>
+            <a:pPr indent="-342900" lvl="0" marL="457200" rtl="0" algn="l">
+              <a:spcBef>
+                <a:spcPts val="0"/>
+              </a:spcBef>
+              <a:spcAft>
+                <a:spcPts val="0"/>
+              </a:spcAft>
+              <a:buSzPts val="1800"/>
+              <a:buChar char="-"/>
+            </a:pPr>
+            <a:r>
+              <a:rPr lang="en"/>
+              <a:t>Token encodings</a:t>
             </a:r>
             <a:endParaRPr/>
           </a:p>
           <a:p>
-            <a:pPr indent="0" lvl="0" marL="0" rtl="0" algn="l">
-              <a:spcBef>
-                <a:spcPts val="1200"/>
-              </a:spcBef>
-              <a:spcAft>
-                <a:spcPts val="0"/>
-              </a:spcAft>
-              <a:buNone/>
+            <a:pPr indent="-342900" lvl="0" marL="457200" rtl="0" algn="l">
+              <a:spcBef>
+                <a:spcPts val="0"/>
+              </a:spcBef>
+              <a:spcAft>
+                <a:spcPts val="0"/>
+              </a:spcAft>
+              <a:buSzPts val="1800"/>
+              <a:buChar char="-"/>
             </a:pPr>
             <a:r>
               <a:rPr lang="en"/>
-              <a:t>MLPs are designed for fixed length vectors</a:t>
+              <a:t>Position encodings</a:t>
             </a:r>
             <a:endParaRPr/>
           </a:p>
           <a:p>
-            <a:pPr indent="0" lvl="0" marL="0" rtl="0" algn="l">
-              <a:spcBef>
-                <a:spcPts val="1200"/>
-              </a:spcBef>
-              <a:spcAft>
-                <a:spcPts val="0"/>
-              </a:spcAft>
-              <a:buNone/>
+            <a:pPr indent="-342900" lvl="0" marL="457200" rtl="0" algn="l">
+              <a:spcBef>
+                <a:spcPts val="0"/>
+              </a:spcBef>
+              <a:spcAft>
+                <a:spcPts val="0"/>
+              </a:spcAft>
+              <a:buSzPts val="1800"/>
+              <a:buChar char="-"/>
             </a:pPr>
             <a:r>
               <a:rPr lang="en"/>
-              <a:t>Text is variable length, and position matters. </a:t>
-            </a:r>
-            <a:endParaRPr/>
-          </a:p>
-          <a:p>
-            <a:pPr indent="0" lvl="0" marL="0" rtl="0" algn="l">
-              <a:spcBef>
-                <a:spcPts val="1200"/>
-              </a:spcBef>
-              <a:spcAft>
-                <a:spcPts val="1200"/>
-              </a:spcAft>
-              <a:buNone/>
-            </a:pPr>
-            <a:r>
-              <a:rPr lang="en"/>
-              <a:t>“Dog bites man” vs “man bites dog”</a:t>
+              <a:t>Transformer-based architectures</a:t>
             </a:r>
             <a:endParaRPr/>
           </a:p>
@@ -11664,215 +12434,6 @@
           <p:cNvPr id="66" name="Google Shape;66;p15"/>
           <p:cNvSpPr txBox="1"/>
           <p:nvPr>
-            <p:ph type="title"/>
-          </p:nvPr>
-        </p:nvSpPr>
-        <p:spPr>
-          <a:xfrm>
-            <a:off x="311700" y="445025"/>
-            <a:ext cx="8520600" cy="572700"/>
-          </a:xfrm>
-          <a:prstGeom prst="rect">
-            <a:avLst/>
-          </a:prstGeom>
-        </p:spPr>
-        <p:txBody>
-          <a:bodyPr anchorCtr="0" anchor="t" bIns="91425" lIns="91425" spcFirstLastPara="1" rIns="91425" wrap="square" tIns="91425">
-            <a:normAutofit fontScale="90000"/>
-          </a:bodyPr>
-          <a:lstStyle/>
-          <a:p>
-            <a:pPr indent="0" lvl="0" marL="0" rtl="0" algn="l">
-              <a:spcBef>
-                <a:spcPts val="0"/>
-              </a:spcBef>
-              <a:spcAft>
-                <a:spcPts val="0"/>
-              </a:spcAft>
-              <a:buNone/>
-            </a:pPr>
-            <a:r>
-              <a:rPr lang="en"/>
-              <a:t>Transformers: Main idea</a:t>
-            </a:r>
-            <a:endParaRPr/>
-          </a:p>
-        </p:txBody>
-      </p:sp>
-      <p:sp>
-        <p:nvSpPr>
-          <p:cNvPr id="67" name="Google Shape;67;p15"/>
-          <p:cNvSpPr txBox="1"/>
-          <p:nvPr>
-            <p:ph idx="1" type="body"/>
-          </p:nvPr>
-        </p:nvSpPr>
-        <p:spPr>
-          <a:xfrm>
-            <a:off x="311700" y="1152475"/>
-            <a:ext cx="8520600" cy="3416400"/>
-          </a:xfrm>
-          <a:prstGeom prst="rect">
-            <a:avLst/>
-          </a:prstGeom>
-        </p:spPr>
-        <p:txBody>
-          <a:bodyPr anchorCtr="0" anchor="t" bIns="91425" lIns="91425" spcFirstLastPara="1" rIns="91425" wrap="square" tIns="91425">
-            <a:normAutofit/>
-          </a:bodyPr>
-          <a:lstStyle/>
-          <a:p>
-            <a:pPr indent="0" lvl="0" marL="0" rtl="0" algn="l">
-              <a:spcBef>
-                <a:spcPts val="0"/>
-              </a:spcBef>
-              <a:spcAft>
-                <a:spcPts val="0"/>
-              </a:spcAft>
-              <a:buNone/>
-            </a:pPr>
-            <a:r>
-              <a:rPr lang="en" sz="1200"/>
-              <a:t>How do I represent a sentence as a fixed length embedding?</a:t>
-            </a:r>
-            <a:endParaRPr sz="1200"/>
-          </a:p>
-          <a:p>
-            <a:pPr indent="0" lvl="0" marL="0" rtl="0" algn="l">
-              <a:spcBef>
-                <a:spcPts val="1200"/>
-              </a:spcBef>
-              <a:spcAft>
-                <a:spcPts val="0"/>
-              </a:spcAft>
-              <a:buNone/>
-            </a:pPr>
-            <a:r>
-              <a:rPr lang="en" sz="1200"/>
-              <a:t>Could</a:t>
-            </a:r>
-            <a:r>
-              <a:rPr lang="en" sz="1200"/>
-              <a:t> take avg/max of each embedding dimension across tokens..</a:t>
-            </a:r>
-            <a:endParaRPr sz="1200"/>
-          </a:p>
-          <a:p>
-            <a:pPr indent="0" lvl="0" marL="0" rtl="0" algn="l">
-              <a:spcBef>
-                <a:spcPts val="1200"/>
-              </a:spcBef>
-              <a:spcAft>
-                <a:spcPts val="0"/>
-              </a:spcAft>
-              <a:buNone/>
-            </a:pPr>
-            <a:r>
-              <a:rPr lang="en" sz="1200"/>
-              <a:t>But this gives equal weight to each token.. When the importance of each token depends on the question you are trying to answer</a:t>
-            </a:r>
-            <a:endParaRPr sz="1200"/>
-          </a:p>
-          <a:p>
-            <a:pPr indent="0" lvl="0" marL="0" rtl="0" algn="l">
-              <a:spcBef>
-                <a:spcPts val="1200"/>
-              </a:spcBef>
-              <a:spcAft>
-                <a:spcPts val="0"/>
-              </a:spcAft>
-              <a:buNone/>
-            </a:pPr>
-            <a:r>
-              <a:rPr lang="en" sz="1200"/>
-              <a:t>Eg., “The food was great but the service was terrible”</a:t>
-            </a:r>
-            <a:endParaRPr sz="1200"/>
-          </a:p>
-          <a:p>
-            <a:pPr indent="0" lvl="0" marL="0" rtl="0" algn="l">
-              <a:spcBef>
-                <a:spcPts val="1200"/>
-              </a:spcBef>
-              <a:spcAft>
-                <a:spcPts val="0"/>
-              </a:spcAft>
-              <a:buNone/>
-            </a:pPr>
-            <a:r>
-              <a:rPr lang="en" sz="1200"/>
-              <a:t>Question: How was the food? Need to understand attribute “great” is bound to food</a:t>
-            </a:r>
-            <a:endParaRPr sz="1200"/>
-          </a:p>
-          <a:p>
-            <a:pPr indent="0" lvl="0" marL="0" rtl="0" algn="l">
-              <a:spcBef>
-                <a:spcPts val="1200"/>
-              </a:spcBef>
-              <a:spcAft>
-                <a:spcPts val="0"/>
-              </a:spcAft>
-              <a:buNone/>
-            </a:pPr>
-            <a:r>
-              <a:rPr lang="en" sz="1200"/>
-              <a:t>Question: How was the service? </a:t>
-            </a:r>
-            <a:r>
-              <a:rPr lang="en" sz="1200"/>
-              <a:t>Need to understand attribute “terrible” is bound to service</a:t>
-            </a:r>
-            <a:endParaRPr sz="1200"/>
-          </a:p>
-          <a:p>
-            <a:pPr indent="0" lvl="0" marL="0" rtl="0" algn="l">
-              <a:spcBef>
-                <a:spcPts val="1200"/>
-              </a:spcBef>
-              <a:spcAft>
-                <a:spcPts val="1200"/>
-              </a:spcAft>
-              <a:buNone/>
-            </a:pPr>
-            <a:r>
-              <a:rPr lang="en" sz="1200"/>
-              <a:t>A flat embedding representation that collapses the token embeddings into a single embedding vector would fail at this task</a:t>
-            </a:r>
-            <a:endParaRPr sz="1200"/>
-          </a:p>
-        </p:txBody>
-      </p:sp>
-    </p:spTree>
-  </p:cSld>
-  <p:clrMapOvr>
-    <a:masterClrMapping/>
-  </p:clrMapOvr>
-</p:sld>
-</file>
-
-<file path=ppt/slides/slide4.xml><?xml version="1.0" encoding="utf-8"?>
-<p:sld xmlns:a="http://schemas.openxmlformats.org/drawingml/2006/main" xmlns:r="http://schemas.openxmlformats.org/officeDocument/2006/relationships" xmlns:mc="http://schemas.openxmlformats.org/markup-compatibility/2006" xmlns:mv="urn:schemas-microsoft-com:mac:vml" xmlns:p="http://schemas.openxmlformats.org/presentationml/2006/main" xmlns:c="http://schemas.openxmlformats.org/drawingml/2006/chart" xmlns:dgm="http://schemas.openxmlformats.org/drawingml/2006/diagram" xmlns:o="urn:schemas-microsoft-com:office:office" xmlns:v="urn:schemas-microsoft-com:vml" xmlns:pvml="urn:schemas-microsoft-com:office:powerpoint" xmlns:com="http://schemas.openxmlformats.org/drawingml/2006/compatibility" xmlns:p14="http://schemas.microsoft.com/office/powerpoint/2010/main" xmlns:p15="http://schemas.microsoft.com/office/powerpoint/2012/main" xmlns:ahyp="http://schemas.microsoft.com/office/drawing/2018/hyperlinkcolor">
-  <p:cSld>
-    <p:spTree>
-      <p:nvGrpSpPr>
-        <p:cNvPr id="71" name="Shape 71"/>
-        <p:cNvGrpSpPr/>
-        <p:nvPr/>
-      </p:nvGrpSpPr>
-      <p:grpSpPr>
-        <a:xfrm>
-          <a:off x="0" y="0"/>
-          <a:ext cx="0" cy="0"/>
-          <a:chOff x="0" y="0"/>
-          <a:chExt cx="0" cy="0"/>
-        </a:xfrm>
-      </p:grpSpPr>
-      <p:sp>
-        <p:nvSpPr>
-          <p:cNvPr id="72" name="Google Shape;72;p16"/>
-          <p:cNvSpPr txBox="1"/>
-          <p:nvPr>
             <p:ph idx="1" type="body"/>
           </p:nvPr>
         </p:nvSpPr>
@@ -11914,7 +12475,7 @@
       </p:sp>
       <p:graphicFrame>
         <p:nvGraphicFramePr>
-          <p:cNvPr id="73" name="Google Shape;73;p16"/>
+          <p:cNvPr id="67" name="Google Shape;67;p15"/>
           <p:cNvGraphicFramePr/>
           <p:nvPr/>
         </p:nvGraphicFramePr>
@@ -11927,7 +12488,7 @@
             <a:tbl>
               <a:tblPr>
                 <a:noFill/>
-                <a:tableStyleId>{CC2E5028-35EF-4173-ACD8-1EDCF5F48ACF}</a:tableStyleId>
+                <a:tableStyleId>{089306F2-FB7C-4637-B24E-8EF8B1EACB90}</a:tableStyleId>
               </a:tblPr>
               <a:tblGrid>
                 <a:gridCol w="504925"/>
@@ -12227,7 +12788,7 @@
       </p:graphicFrame>
       <p:graphicFrame>
         <p:nvGraphicFramePr>
-          <p:cNvPr id="74" name="Google Shape;74;p16"/>
+          <p:cNvPr id="68" name="Google Shape;68;p15"/>
           <p:cNvGraphicFramePr/>
           <p:nvPr/>
         </p:nvGraphicFramePr>
@@ -12240,7 +12801,7 @@
             <a:tbl>
               <a:tblPr>
                 <a:noFill/>
-                <a:tableStyleId>{CC2E5028-35EF-4173-ACD8-1EDCF5F48ACF}</a:tableStyleId>
+                <a:tableStyleId>{089306F2-FB7C-4637-B24E-8EF8B1EACB90}</a:tableStyleId>
               </a:tblPr>
               <a:tblGrid>
                 <a:gridCol w="504925"/>
@@ -12540,7 +13101,7 @@
       </p:graphicFrame>
       <p:graphicFrame>
         <p:nvGraphicFramePr>
-          <p:cNvPr id="75" name="Google Shape;75;p16"/>
+          <p:cNvPr id="69" name="Google Shape;69;p15"/>
           <p:cNvGraphicFramePr/>
           <p:nvPr/>
         </p:nvGraphicFramePr>
@@ -12553,7 +13114,7 @@
             <a:tbl>
               <a:tblPr>
                 <a:noFill/>
-                <a:tableStyleId>{CC2E5028-35EF-4173-ACD8-1EDCF5F48ACF}</a:tableStyleId>
+                <a:tableStyleId>{089306F2-FB7C-4637-B24E-8EF8B1EACB90}</a:tableStyleId>
               </a:tblPr>
               <a:tblGrid>
                 <a:gridCol w="504925"/>
@@ -12861,7 +13422,7 @@
       </p:graphicFrame>
       <p:graphicFrame>
         <p:nvGraphicFramePr>
-          <p:cNvPr id="76" name="Google Shape;76;p16"/>
+          <p:cNvPr id="70" name="Google Shape;70;p15"/>
           <p:cNvGraphicFramePr/>
           <p:nvPr/>
         </p:nvGraphicFramePr>
@@ -12874,7 +13435,7 @@
             <a:tbl>
               <a:tblPr>
                 <a:noFill/>
-                <a:tableStyleId>{CC2E5028-35EF-4173-ACD8-1EDCF5F48ACF}</a:tableStyleId>
+                <a:tableStyleId>{089306F2-FB7C-4637-B24E-8EF8B1EACB90}</a:tableStyleId>
               </a:tblPr>
               <a:tblGrid>
                 <a:gridCol w="2019650"/>
@@ -12910,7 +13471,7 @@
       </p:graphicFrame>
       <p:graphicFrame>
         <p:nvGraphicFramePr>
-          <p:cNvPr id="77" name="Google Shape;77;p16"/>
+          <p:cNvPr id="71" name="Google Shape;71;p15"/>
           <p:cNvGraphicFramePr/>
           <p:nvPr/>
         </p:nvGraphicFramePr>
@@ -12923,7 +13484,7 @@
             <a:tbl>
               <a:tblPr>
                 <a:noFill/>
-                <a:tableStyleId>{CC2E5028-35EF-4173-ACD8-1EDCF5F48ACF}</a:tableStyleId>
+                <a:tableStyleId>{089306F2-FB7C-4637-B24E-8EF8B1EACB90}</a:tableStyleId>
               </a:tblPr>
               <a:tblGrid>
                 <a:gridCol w="2019650"/>
@@ -12959,7 +13520,7 @@
       </p:graphicFrame>
       <p:graphicFrame>
         <p:nvGraphicFramePr>
-          <p:cNvPr id="78" name="Google Shape;78;p16"/>
+          <p:cNvPr id="72" name="Google Shape;72;p15"/>
           <p:cNvGraphicFramePr/>
           <p:nvPr/>
         </p:nvGraphicFramePr>
@@ -12972,7 +13533,7 @@
             <a:tbl>
               <a:tblPr>
                 <a:noFill/>
-                <a:tableStyleId>{CC2E5028-35EF-4173-ACD8-1EDCF5F48ACF}</a:tableStyleId>
+                <a:tableStyleId>{089306F2-FB7C-4637-B24E-8EF8B1EACB90}</a:tableStyleId>
               </a:tblPr>
               <a:tblGrid>
                 <a:gridCol w="865350"/>
@@ -13008,7 +13569,7 @@
       </p:graphicFrame>
       <p:sp>
         <p:nvSpPr>
-          <p:cNvPr id="79" name="Google Shape;79;p16"/>
+          <p:cNvPr id="73" name="Google Shape;73;p15"/>
           <p:cNvSpPr txBox="1"/>
           <p:nvPr>
             <p:ph type="title"/>
@@ -13048,7 +13609,7 @@
       </p:sp>
       <p:graphicFrame>
         <p:nvGraphicFramePr>
-          <p:cNvPr id="80" name="Google Shape;80;p16"/>
+          <p:cNvPr id="74" name="Google Shape;74;p15"/>
           <p:cNvGraphicFramePr/>
           <p:nvPr/>
         </p:nvGraphicFramePr>
@@ -13061,7 +13622,7 @@
             <a:tbl>
               <a:tblPr>
                 <a:noFill/>
-                <a:tableStyleId>{CC2E5028-35EF-4173-ACD8-1EDCF5F48ACF}</a:tableStyleId>
+                <a:tableStyleId>{089306F2-FB7C-4637-B24E-8EF8B1EACB90}</a:tableStyleId>
               </a:tblPr>
               <a:tblGrid>
                 <a:gridCol w="865350"/>
@@ -13097,7 +13658,7 @@
       </p:graphicFrame>
       <p:cxnSp>
         <p:nvCxnSpPr>
-          <p:cNvPr id="81" name="Google Shape;81;p16"/>
+          <p:cNvPr id="75" name="Google Shape;75;p15"/>
           <p:cNvCxnSpPr/>
           <p:nvPr/>
         </p:nvCxnSpPr>
@@ -13123,7 +13684,7 @@
       </p:cxnSp>
       <p:cxnSp>
         <p:nvCxnSpPr>
-          <p:cNvPr id="82" name="Google Shape;82;p16"/>
+          <p:cNvPr id="76" name="Google Shape;76;p15"/>
           <p:cNvCxnSpPr/>
           <p:nvPr/>
         </p:nvCxnSpPr>
@@ -13149,7 +13710,7 @@
       </p:cxnSp>
       <p:cxnSp>
         <p:nvCxnSpPr>
-          <p:cNvPr id="83" name="Google Shape;83;p16"/>
+          <p:cNvPr id="77" name="Google Shape;77;p15"/>
           <p:cNvCxnSpPr/>
           <p:nvPr/>
         </p:nvCxnSpPr>
@@ -13175,7 +13736,7 @@
       </p:cxnSp>
       <p:cxnSp>
         <p:nvCxnSpPr>
-          <p:cNvPr id="84" name="Google Shape;84;p16"/>
+          <p:cNvPr id="78" name="Google Shape;78;p15"/>
           <p:cNvCxnSpPr/>
           <p:nvPr/>
         </p:nvCxnSpPr>
@@ -13201,7 +13762,7 @@
       </p:cxnSp>
       <p:sp>
         <p:nvSpPr>
-          <p:cNvPr id="85" name="Google Shape;85;p16"/>
+          <p:cNvPr id="79" name="Google Shape;79;p15"/>
           <p:cNvSpPr txBox="1"/>
           <p:nvPr/>
         </p:nvSpPr>
@@ -13251,7 +13812,7 @@
       </p:sp>
       <p:sp>
         <p:nvSpPr>
-          <p:cNvPr id="86" name="Google Shape;86;p16"/>
+          <p:cNvPr id="80" name="Google Shape;80;p15"/>
           <p:cNvSpPr txBox="1"/>
           <p:nvPr/>
         </p:nvSpPr>
@@ -13301,7 +13862,7 @@
       </p:sp>
       <p:sp>
         <p:nvSpPr>
-          <p:cNvPr id="87" name="Google Shape;87;p16"/>
+          <p:cNvPr id="81" name="Google Shape;81;p15"/>
           <p:cNvSpPr txBox="1"/>
           <p:nvPr/>
         </p:nvSpPr>
@@ -13351,7 +13912,7 @@
       </p:sp>
       <p:sp>
         <p:nvSpPr>
-          <p:cNvPr id="88" name="Google Shape;88;p16"/>
+          <p:cNvPr id="82" name="Google Shape;82;p15"/>
           <p:cNvSpPr txBox="1"/>
           <p:nvPr/>
         </p:nvSpPr>
@@ -13401,7 +13962,7 @@
       </p:sp>
       <p:graphicFrame>
         <p:nvGraphicFramePr>
-          <p:cNvPr id="89" name="Google Shape;89;p16"/>
+          <p:cNvPr id="83" name="Google Shape;83;p15"/>
           <p:cNvGraphicFramePr/>
           <p:nvPr/>
         </p:nvGraphicFramePr>
@@ -13414,7 +13975,7 @@
             <a:tbl>
               <a:tblPr>
                 <a:noFill/>
-                <a:tableStyleId>{CC2E5028-35EF-4173-ACD8-1EDCF5F48ACF}</a:tableStyleId>
+                <a:tableStyleId>{089306F2-FB7C-4637-B24E-8EF8B1EACB90}</a:tableStyleId>
               </a:tblPr>
               <a:tblGrid>
                 <a:gridCol w="1389800"/>
@@ -13450,7 +14011,7 @@
       </p:graphicFrame>
       <p:cxnSp>
         <p:nvCxnSpPr>
-          <p:cNvPr id="90" name="Google Shape;90;p16"/>
+          <p:cNvPr id="84" name="Google Shape;84;p15"/>
           <p:cNvCxnSpPr/>
           <p:nvPr/>
         </p:nvCxnSpPr>
@@ -13476,7 +14037,7 @@
       </p:cxnSp>
       <p:sp>
         <p:nvSpPr>
-          <p:cNvPr id="91" name="Google Shape;91;p16"/>
+          <p:cNvPr id="85" name="Google Shape;85;p15"/>
           <p:cNvSpPr txBox="1"/>
           <p:nvPr/>
         </p:nvSpPr>
@@ -13598,7 +14159,7 @@
       </p:sp>
       <p:sp>
         <p:nvSpPr>
-          <p:cNvPr id="92" name="Google Shape;92;p16"/>
+          <p:cNvPr id="86" name="Google Shape;86;p15"/>
           <p:cNvSpPr txBox="1"/>
           <p:nvPr/>
         </p:nvSpPr>
@@ -13643,6 +14204,199 @@
                 <a:schemeClr val="dk2"/>
               </a:solidFill>
             </a:endParaRPr>
+          </a:p>
+        </p:txBody>
+      </p:sp>
+    </p:spTree>
+  </p:cSld>
+  <p:clrMapOvr>
+    <a:masterClrMapping/>
+  </p:clrMapOvr>
+</p:sld>
+</file>
+
+<file path=ppt/slides/slide4.xml><?xml version="1.0" encoding="utf-8"?>
+<p:sld xmlns:a="http://schemas.openxmlformats.org/drawingml/2006/main" xmlns:r="http://schemas.openxmlformats.org/officeDocument/2006/relationships" xmlns:mc="http://schemas.openxmlformats.org/markup-compatibility/2006" xmlns:mv="urn:schemas-microsoft-com:mac:vml" xmlns:p="http://schemas.openxmlformats.org/presentationml/2006/main" xmlns:c="http://schemas.openxmlformats.org/drawingml/2006/chart" xmlns:dgm="http://schemas.openxmlformats.org/drawingml/2006/diagram" xmlns:o="urn:schemas-microsoft-com:office:office" xmlns:v="urn:schemas-microsoft-com:vml" xmlns:pvml="urn:schemas-microsoft-com:office:powerpoint" xmlns:com="http://schemas.openxmlformats.org/drawingml/2006/compatibility" xmlns:p14="http://schemas.microsoft.com/office/powerpoint/2010/main" xmlns:p15="http://schemas.microsoft.com/office/powerpoint/2012/main" xmlns:ahyp="http://schemas.microsoft.com/office/drawing/2018/hyperlinkcolor">
+  <p:cSld>
+    <p:spTree>
+      <p:nvGrpSpPr>
+        <p:cNvPr id="90" name="Shape 90"/>
+        <p:cNvGrpSpPr/>
+        <p:nvPr/>
+      </p:nvGrpSpPr>
+      <p:grpSpPr>
+        <a:xfrm>
+          <a:off x="0" y="0"/>
+          <a:ext cx="0" cy="0"/>
+          <a:chOff x="0" y="0"/>
+          <a:chExt cx="0" cy="0"/>
+        </a:xfrm>
+      </p:grpSpPr>
+      <p:sp>
+        <p:nvSpPr>
+          <p:cNvPr id="91" name="Google Shape;91;p16"/>
+          <p:cNvSpPr txBox="1"/>
+          <p:nvPr>
+            <p:ph type="title"/>
+          </p:nvPr>
+        </p:nvSpPr>
+        <p:spPr>
+          <a:xfrm>
+            <a:off x="311700" y="445025"/>
+            <a:ext cx="8520600" cy="572700"/>
+          </a:xfrm>
+          <a:prstGeom prst="rect">
+            <a:avLst/>
+          </a:prstGeom>
+        </p:spPr>
+        <p:txBody>
+          <a:bodyPr anchorCtr="0" anchor="t" bIns="91425" lIns="91425" spcFirstLastPara="1" rIns="91425" wrap="square" tIns="91425">
+            <a:normAutofit fontScale="90000"/>
+          </a:bodyPr>
+          <a:lstStyle/>
+          <a:p>
+            <a:pPr indent="0" lvl="0" marL="0" rtl="0" algn="l">
+              <a:spcBef>
+                <a:spcPts val="0"/>
+              </a:spcBef>
+              <a:spcAft>
+                <a:spcPts val="0"/>
+              </a:spcAft>
+              <a:buNone/>
+            </a:pPr>
+            <a:r>
+              <a:rPr lang="en"/>
+              <a:t>Attention</a:t>
+            </a:r>
+            <a:endParaRPr/>
+          </a:p>
+        </p:txBody>
+      </p:sp>
+      <p:sp>
+        <p:nvSpPr>
+          <p:cNvPr id="92" name="Google Shape;92;p16"/>
+          <p:cNvSpPr txBox="1"/>
+          <p:nvPr>
+            <p:ph idx="1" type="body"/>
+          </p:nvPr>
+        </p:nvSpPr>
+        <p:spPr>
+          <a:xfrm>
+            <a:off x="676450" y="1550100"/>
+            <a:ext cx="6807900" cy="2477400"/>
+          </a:xfrm>
+          <a:prstGeom prst="rect">
+            <a:avLst/>
+          </a:prstGeom>
+        </p:spPr>
+        <p:txBody>
+          <a:bodyPr anchorCtr="0" anchor="t" bIns="91425" lIns="91425" spcFirstLastPara="1" rIns="91425" wrap="square" tIns="91425">
+            <a:normAutofit fontScale="92500"/>
+          </a:bodyPr>
+          <a:lstStyle/>
+          <a:p>
+            <a:pPr indent="0" lvl="0" marL="0" rtl="0" algn="l">
+              <a:spcBef>
+                <a:spcPts val="0"/>
+              </a:spcBef>
+              <a:spcAft>
+                <a:spcPts val="0"/>
+              </a:spcAft>
+              <a:buNone/>
+            </a:pPr>
+            <a:r>
+              <a:rPr b="1" lang="en" sz="1300"/>
+              <a:t>Query</a:t>
+            </a:r>
+            <a:r>
+              <a:rPr lang="en" sz="1300"/>
+              <a:t> is the token for which we are trying to determine relevant tokens. Query is the token for which we are trying to define “what should this token look at, in the current context?”</a:t>
+            </a:r>
+            <a:endParaRPr sz="1300"/>
+          </a:p>
+          <a:p>
+            <a:pPr indent="0" lvl="0" marL="0" rtl="0" algn="l">
+              <a:spcBef>
+                <a:spcPts val="1200"/>
+              </a:spcBef>
+              <a:spcAft>
+                <a:spcPts val="0"/>
+              </a:spcAft>
+              <a:buNone/>
+            </a:pPr>
+            <a:r>
+              <a:rPr lang="en" sz="1300"/>
+              <a:t>Eg: “food was great but the service was terrible”</a:t>
+            </a:r>
+            <a:endParaRPr sz="1300"/>
+          </a:p>
+          <a:p>
+            <a:pPr indent="0" lvl="0" marL="0" rtl="0" algn="l">
+              <a:spcBef>
+                <a:spcPts val="1200"/>
+              </a:spcBef>
+              <a:spcAft>
+                <a:spcPts val="0"/>
+              </a:spcAft>
+              <a:buNone/>
+            </a:pPr>
+            <a:r>
+              <a:rPr lang="en" sz="1300"/>
+              <a:t>For query = sentiment, tokens </a:t>
+            </a:r>
+            <a:r>
+              <a:rPr i="1" lang="en" sz="1300"/>
+              <a:t>great</a:t>
+            </a:r>
+            <a:r>
+              <a:rPr lang="en" sz="1300"/>
+              <a:t> and </a:t>
+            </a:r>
+            <a:r>
+              <a:rPr i="1" lang="en" sz="1300"/>
+              <a:t>terrible</a:t>
+            </a:r>
+            <a:r>
+              <a:rPr lang="en" sz="1300"/>
+              <a:t> should be important</a:t>
+            </a:r>
+            <a:endParaRPr sz="1300"/>
+          </a:p>
+          <a:p>
+            <a:pPr indent="0" lvl="0" marL="0" rtl="0" algn="l">
+              <a:spcBef>
+                <a:spcPts val="1200"/>
+              </a:spcBef>
+              <a:spcAft>
+                <a:spcPts val="0"/>
+              </a:spcAft>
+              <a:buNone/>
+            </a:pPr>
+            <a:r>
+              <a:rPr lang="en" sz="1300"/>
+              <a:t>Query can come from another sentence, eg., in the context of language translation, or from the same sentence--”which tokens do I care about”? </a:t>
+            </a:r>
+            <a:endParaRPr sz="1300"/>
+          </a:p>
+          <a:p>
+            <a:pPr indent="0" lvl="0" marL="0" rtl="0" algn="l">
+              <a:spcBef>
+                <a:spcPts val="1200"/>
+              </a:spcBef>
+              <a:spcAft>
+                <a:spcPts val="1200"/>
+              </a:spcAft>
+              <a:buNone/>
+            </a:pPr>
+            <a:r>
+              <a:rPr b="1" lang="en" sz="1300"/>
+              <a:t>Attention: </a:t>
+            </a:r>
+            <a:r>
+              <a:rPr i="1" lang="en" sz="1300"/>
+              <a:t>Given a query q, which tokens in the sequence are relevant, and what information should we extract from them?</a:t>
+            </a:r>
+            <a:endParaRPr i="1" sz="1300"/>
           </a:p>
         </p:txBody>
       </p:sp>
@@ -13701,11 +14455,31 @@
               <a:spcAft>
                 <a:spcPts val="0"/>
               </a:spcAft>
+              <a:buClr>
+                <a:schemeClr val="dk1"/>
+              </a:buClr>
+              <a:buSzPct val="39285"/>
+              <a:buFont typeface="Arial"/>
               <a:buNone/>
             </a:pPr>
             <a:r>
               <a:rPr lang="en"/>
               <a:t>Attention</a:t>
+            </a:r>
+            <a:endParaRPr/>
+          </a:p>
+          <a:p>
+            <a:pPr indent="0" lvl="0" marL="0" rtl="0" algn="l">
+              <a:spcBef>
+                <a:spcPts val="0"/>
+              </a:spcBef>
+              <a:spcAft>
+                <a:spcPts val="0"/>
+              </a:spcAft>
+              <a:buNone/>
+            </a:pPr>
+            <a:r>
+              <a:t/>
             </a:r>
             <a:endParaRPr/>
           </a:p>
@@ -13714,219 +14488,6 @@
       <p:sp>
         <p:nvSpPr>
           <p:cNvPr id="98" name="Google Shape;98;p17"/>
-          <p:cNvSpPr txBox="1"/>
-          <p:nvPr>
-            <p:ph idx="1" type="body"/>
-          </p:nvPr>
-        </p:nvSpPr>
-        <p:spPr>
-          <a:xfrm>
-            <a:off x="676450" y="1550100"/>
-            <a:ext cx="6807900" cy="2477400"/>
-          </a:xfrm>
-          <a:prstGeom prst="rect">
-            <a:avLst/>
-          </a:prstGeom>
-        </p:spPr>
-        <p:txBody>
-          <a:bodyPr anchorCtr="0" anchor="t" bIns="91425" lIns="91425" spcFirstLastPara="1" rIns="91425" wrap="square" tIns="91425">
-            <a:normAutofit lnSpcReduction="10000"/>
-          </a:bodyPr>
-          <a:lstStyle/>
-          <a:p>
-            <a:pPr indent="0" lvl="0" marL="0" rtl="0" algn="l">
-              <a:spcBef>
-                <a:spcPts val="0"/>
-              </a:spcBef>
-              <a:spcAft>
-                <a:spcPts val="0"/>
-              </a:spcAft>
-              <a:buNone/>
-            </a:pPr>
-            <a:r>
-              <a:rPr b="1" lang="en" sz="1300"/>
-              <a:t>Query</a:t>
-            </a:r>
-            <a:r>
-              <a:rPr lang="en" sz="1300"/>
-              <a:t> is the token for which we are trying to determine relevant tokens. Query is the token for which we are trying to define “what should this token look at?”</a:t>
-            </a:r>
-            <a:endParaRPr sz="1300"/>
-          </a:p>
-          <a:p>
-            <a:pPr indent="0" lvl="0" marL="0" rtl="0" algn="l">
-              <a:spcBef>
-                <a:spcPts val="1200"/>
-              </a:spcBef>
-              <a:spcAft>
-                <a:spcPts val="0"/>
-              </a:spcAft>
-              <a:buNone/>
-            </a:pPr>
-            <a:r>
-              <a:rPr lang="en" sz="1300"/>
-              <a:t>Eg: “food was great but the service was terrible”</a:t>
-            </a:r>
-            <a:endParaRPr sz="1300"/>
-          </a:p>
-          <a:p>
-            <a:pPr indent="0" lvl="0" marL="0" rtl="0" algn="l">
-              <a:spcBef>
-                <a:spcPts val="1200"/>
-              </a:spcBef>
-              <a:spcAft>
-                <a:spcPts val="0"/>
-              </a:spcAft>
-              <a:buNone/>
-            </a:pPr>
-            <a:r>
-              <a:rPr lang="en" sz="1300"/>
-              <a:t>For query = sentiment, tokens </a:t>
-            </a:r>
-            <a:r>
-              <a:rPr i="1" lang="en" sz="1300"/>
-              <a:t>great</a:t>
-            </a:r>
-            <a:r>
-              <a:rPr lang="en" sz="1300"/>
-              <a:t> and </a:t>
-            </a:r>
-            <a:r>
-              <a:rPr i="1" lang="en" sz="1300"/>
-              <a:t>terrible</a:t>
-            </a:r>
-            <a:r>
-              <a:rPr lang="en" sz="1300"/>
-              <a:t> should be important</a:t>
-            </a:r>
-            <a:endParaRPr sz="1300"/>
-          </a:p>
-          <a:p>
-            <a:pPr indent="0" lvl="0" marL="0" rtl="0" algn="l">
-              <a:spcBef>
-                <a:spcPts val="1200"/>
-              </a:spcBef>
-              <a:spcAft>
-                <a:spcPts val="0"/>
-              </a:spcAft>
-              <a:buNone/>
-            </a:pPr>
-            <a:r>
-              <a:rPr lang="en" sz="1300"/>
-              <a:t>Query can come from another sentence, eg., in the context of language translation, or from the same sentence--”which tokens do I care about”? </a:t>
-            </a:r>
-            <a:endParaRPr sz="1300"/>
-          </a:p>
-          <a:p>
-            <a:pPr indent="0" lvl="0" marL="0" rtl="0" algn="l">
-              <a:spcBef>
-                <a:spcPts val="1200"/>
-              </a:spcBef>
-              <a:spcAft>
-                <a:spcPts val="1200"/>
-              </a:spcAft>
-              <a:buNone/>
-            </a:pPr>
-            <a:r>
-              <a:rPr b="1" lang="en" sz="1300"/>
-              <a:t>Attention: </a:t>
-            </a:r>
-            <a:r>
-              <a:rPr i="1" lang="en" sz="1300"/>
-              <a:t>Given a query q, which tokens in the sequence are relevant, and what information should we extract from them?</a:t>
-            </a:r>
-            <a:endParaRPr i="1" sz="1300"/>
-          </a:p>
-        </p:txBody>
-      </p:sp>
-    </p:spTree>
-  </p:cSld>
-  <p:clrMapOvr>
-    <a:masterClrMapping/>
-  </p:clrMapOvr>
-</p:sld>
-</file>
-
-<file path=ppt/slides/slide6.xml><?xml version="1.0" encoding="utf-8"?>
-<p:sld xmlns:a="http://schemas.openxmlformats.org/drawingml/2006/main" xmlns:r="http://schemas.openxmlformats.org/officeDocument/2006/relationships" xmlns:mc="http://schemas.openxmlformats.org/markup-compatibility/2006" xmlns:mv="urn:schemas-microsoft-com:mac:vml" xmlns:p="http://schemas.openxmlformats.org/presentationml/2006/main" xmlns:c="http://schemas.openxmlformats.org/drawingml/2006/chart" xmlns:dgm="http://schemas.openxmlformats.org/drawingml/2006/diagram" xmlns:o="urn:schemas-microsoft-com:office:office" xmlns:v="urn:schemas-microsoft-com:vml" xmlns:pvml="urn:schemas-microsoft-com:office:powerpoint" xmlns:com="http://schemas.openxmlformats.org/drawingml/2006/compatibility" xmlns:p14="http://schemas.microsoft.com/office/powerpoint/2010/main" xmlns:p15="http://schemas.microsoft.com/office/powerpoint/2012/main" xmlns:ahyp="http://schemas.microsoft.com/office/drawing/2018/hyperlinkcolor">
-  <p:cSld>
-    <p:spTree>
-      <p:nvGrpSpPr>
-        <p:cNvPr id="102" name="Shape 102"/>
-        <p:cNvGrpSpPr/>
-        <p:nvPr/>
-      </p:nvGrpSpPr>
-      <p:grpSpPr>
-        <a:xfrm>
-          <a:off x="0" y="0"/>
-          <a:ext cx="0" cy="0"/>
-          <a:chOff x="0" y="0"/>
-          <a:chExt cx="0" cy="0"/>
-        </a:xfrm>
-      </p:grpSpPr>
-      <p:sp>
-        <p:nvSpPr>
-          <p:cNvPr id="103" name="Google Shape;103;p18"/>
-          <p:cNvSpPr txBox="1"/>
-          <p:nvPr>
-            <p:ph type="title"/>
-          </p:nvPr>
-        </p:nvSpPr>
-        <p:spPr>
-          <a:xfrm>
-            <a:off x="311700" y="445025"/>
-            <a:ext cx="8520600" cy="572700"/>
-          </a:xfrm>
-          <a:prstGeom prst="rect">
-            <a:avLst/>
-          </a:prstGeom>
-        </p:spPr>
-        <p:txBody>
-          <a:bodyPr anchorCtr="0" anchor="t" bIns="91425" lIns="91425" spcFirstLastPara="1" rIns="91425" wrap="square" tIns="91425">
-            <a:normAutofit fontScale="90000"/>
-          </a:bodyPr>
-          <a:lstStyle/>
-          <a:p>
-            <a:pPr indent="0" lvl="0" marL="0" rtl="0" algn="l">
-              <a:spcBef>
-                <a:spcPts val="0"/>
-              </a:spcBef>
-              <a:spcAft>
-                <a:spcPts val="0"/>
-              </a:spcAft>
-              <a:buClr>
-                <a:schemeClr val="dk1"/>
-              </a:buClr>
-              <a:buSzPct val="39285"/>
-              <a:buFont typeface="Arial"/>
-              <a:buNone/>
-            </a:pPr>
-            <a:r>
-              <a:rPr lang="en"/>
-              <a:t>Attention</a:t>
-            </a:r>
-            <a:endParaRPr/>
-          </a:p>
-          <a:p>
-            <a:pPr indent="0" lvl="0" marL="0" rtl="0" algn="l">
-              <a:spcBef>
-                <a:spcPts val="0"/>
-              </a:spcBef>
-              <a:spcAft>
-                <a:spcPts val="0"/>
-              </a:spcAft>
-              <a:buNone/>
-            </a:pPr>
-            <a:r>
-              <a:t/>
-            </a:r>
-            <a:endParaRPr/>
-          </a:p>
-        </p:txBody>
-      </p:sp>
-      <p:sp>
-        <p:nvSpPr>
-          <p:cNvPr id="104" name="Google Shape;104;p18"/>
           <p:cNvSpPr txBox="1"/>
           <p:nvPr>
             <p:ph idx="1" type="body"/>
@@ -13970,7 +14531,7 @@
       </p:sp>
       <p:pic>
         <p:nvPicPr>
-          <p:cNvPr descr="{&quot;backgroundColorModified&quot;:false,&quot;backgroundColor&quot;:&quot;#FFFFFF&quot;,&quot;id&quot;:&quot;1&quot;,&quot;type&quot;:&quot;gather*&quot;,&quot;aid&quot;:null,&quot;code&quot;:&quot;\\begin{gather*}\n{\\text{h=}\\sum_{i=1}^{L}\\alpha_{i}x_{i}}\\\\\n{\\sum_{i=1}^{L}\\alpha_{i}=1,\\,\\alpha_{i}\\geq0}\\\\\n{\\text{We}\\;\\text{need}\\;\\text{a}\\;\\text{scoring}\\;\\text{function}\\;\\text{that}\\;\\text{says}\\;\\text{how}\\;\\text{relevant}\\;\\text{each}\\,\\text{sentence}\\;\\text{token}\\;\\text{is}\\,\\text{to}\\;\\text{the}\\;\\text{query}\\;\\text{token.}}\\\\\n{\\text{The}\\;\\text{scoring}\\;\\text{function}\\;\\text{outputs}\\;\\text{scores}\\;s_{i},\\,\\text{which}\\;\\text{can}\\;\\text{be}\\;\\text{converted}\\;\\text{into}\\;\\alpha_{i}}\\\\\n{\\text{by}\\;\\text{applying}\\;\\text{softmax}}\\\\\n{\\alpha_{i}=\\frac{\\exp\\left(s_{i}\\right)}{\\sum_{j=1}^{L}\\exp\\left(s_{j}\\right)}}\\\\\n{\\text{How}\\;\\text{do}\\;\\text{we}\\;\\text{get}\\;\\text{the}\\;\\text{scores}\\;s_{j}?}\t\n\\end{gather*}&quot;,&quot;font&quot;:{&quot;size&quot;:12,&quot;family&quot;:&quot;Arial&quot;,&quot;color&quot;:&quot;#000000&quot;},&quot;ts&quot;:1772542398191,&quot;cs&quot;:&quot;EG0dtWiFJAEmulB11fdplw==&quot;,&quot;size&quot;:{&quot;width&quot;:748,&quot;height&quot;:272.99999999999994}}" id="105" name="Google Shape;105;p18"/>
+          <p:cNvPr descr="{&quot;backgroundColorModified&quot;:false,&quot;backgroundColor&quot;:&quot;#FFFFFF&quot;,&quot;id&quot;:&quot;1&quot;,&quot;type&quot;:&quot;gather*&quot;,&quot;aid&quot;:null,&quot;code&quot;:&quot;\\begin{gather*}\n{\\text{h=}\\sum_{i=1}^{L}\\alpha_{i}x_{i}}\\\\\n{\\sum_{i=1}^{L}\\alpha_{i}=1,\\,\\alpha_{i}\\geq0}\\\\\n{\\text{We}\\;\\text{need}\\;\\text{a}\\;\\text{scoring}\\;\\text{function}\\;\\text{that}\\;\\text{says}\\;\\text{how}\\;\\text{relevant}\\;\\text{each}\\,\\text{sentence}\\;\\text{token}\\;\\text{is}\\,\\text{to}\\;\\text{the}\\;\\text{query}\\;\\text{token.}}\\\\\n{\\text{The}\\;\\text{scoring}\\;\\text{function}\\;\\text{outputs}\\;\\text{scores}\\;s_{i},\\,\\text{which}\\;\\text{can}\\;\\text{be}\\;\\text{converted}\\;\\text{into}\\;\\alpha_{i}}\\\\\n{\\text{by}\\;\\text{applying}\\;\\text{softmax}}\\\\\n{\\alpha_{i}=\\frac{\\exp\\left(s_{i}\\right)}{\\sum_{j=1}^{L}\\exp\\left(s_{j}\\right)}}\\\\\n{\\text{How}\\;\\text{do}\\;\\text{we}\\;\\text{get}\\;\\text{the}\\;\\text{scores}\\;s_{j}?}\t\n\\end{gather*}&quot;,&quot;font&quot;:{&quot;size&quot;:12,&quot;family&quot;:&quot;Arial&quot;,&quot;color&quot;:&quot;#000000&quot;},&quot;ts&quot;:1772542398191,&quot;cs&quot;:&quot;EG0dtWiFJAEmulB11fdplw==&quot;,&quot;size&quot;:{&quot;width&quot;:748,&quot;height&quot;:272.99999999999994}}" id="99" name="Google Shape;99;p17"/>
           <p:cNvPicPr preferRelativeResize="0"/>
           <p:nvPr/>
         </p:nvPicPr>
@@ -14004,12 +14565,12 @@
 </p:sld>
 </file>
 
-<file path=ppt/slides/slide7.xml><?xml version="1.0" encoding="utf-8"?>
+<file path=ppt/slides/slide6.xml><?xml version="1.0" encoding="utf-8"?>
 <p:sld xmlns:a="http://schemas.openxmlformats.org/drawingml/2006/main" xmlns:r="http://schemas.openxmlformats.org/officeDocument/2006/relationships" xmlns:mc="http://schemas.openxmlformats.org/markup-compatibility/2006" xmlns:mv="urn:schemas-microsoft-com:mac:vml" xmlns:p="http://schemas.openxmlformats.org/presentationml/2006/main" xmlns:c="http://schemas.openxmlformats.org/drawingml/2006/chart" xmlns:dgm="http://schemas.openxmlformats.org/drawingml/2006/diagram" xmlns:o="urn:schemas-microsoft-com:office:office" xmlns:v="urn:schemas-microsoft-com:vml" xmlns:pvml="urn:schemas-microsoft-com:office:powerpoint" xmlns:com="http://schemas.openxmlformats.org/drawingml/2006/compatibility" xmlns:p14="http://schemas.microsoft.com/office/powerpoint/2010/main" xmlns:p15="http://schemas.microsoft.com/office/powerpoint/2012/main" xmlns:ahyp="http://schemas.microsoft.com/office/drawing/2018/hyperlinkcolor">
   <p:cSld>
     <p:spTree>
       <p:nvGrpSpPr>
-        <p:cNvPr id="109" name="Shape 109"/>
+        <p:cNvPr id="103" name="Shape 103"/>
         <p:cNvGrpSpPr/>
         <p:nvPr/>
       </p:nvGrpSpPr>
@@ -14023,7 +14584,7 @@
       </p:grpSpPr>
       <p:sp>
         <p:nvSpPr>
-          <p:cNvPr id="110" name="Google Shape;110;p19"/>
+          <p:cNvPr id="104" name="Google Shape;104;p18"/>
           <p:cNvSpPr txBox="1"/>
           <p:nvPr>
             <p:ph type="title"/>
@@ -14063,7 +14624,7 @@
       </p:sp>
       <p:sp>
         <p:nvSpPr>
-          <p:cNvPr id="111" name="Google Shape;111;p19"/>
+          <p:cNvPr id="105" name="Google Shape;105;p18"/>
           <p:cNvSpPr txBox="1"/>
           <p:nvPr>
             <p:ph idx="1" type="body"/>
@@ -14080,81 +14641,118 @@
         </p:spPr>
         <p:txBody>
           <a:bodyPr anchorCtr="0" anchor="t" bIns="91425" lIns="91425" spcFirstLastPara="1" rIns="91425" wrap="square" tIns="91425">
-            <a:normAutofit fontScale="47500" lnSpcReduction="10000"/>
+            <a:noAutofit/>
           </a:bodyPr>
           <a:lstStyle/>
           <a:p>
             <a:pPr indent="0" lvl="0" marL="0" rtl="0" algn="l">
-              <a:spcBef>
-                <a:spcPts val="0"/>
-              </a:spcBef>
-              <a:spcAft>
-                <a:spcPts val="0"/>
-              </a:spcAft>
+              <a:lnSpc>
+                <a:spcPct val="105000"/>
+              </a:lnSpc>
+              <a:spcBef>
+                <a:spcPts val="0"/>
+              </a:spcBef>
+              <a:spcAft>
+                <a:spcPts val="0"/>
+              </a:spcAft>
+              <a:buSzPts val="523"/>
               <a:buNone/>
             </a:pPr>
             <a:r>
-              <a:rPr lang="en"/>
+              <a:rPr lang="en" sz="955"/>
               <a:t>Rather than using pure embeddings we need to learn mappings Wq, Wk, Wv to:</a:t>
             </a:r>
-            <a:endParaRPr/>
+            <a:endParaRPr sz="955"/>
           </a:p>
           <a:p>
-            <a:pPr indent="-282892" lvl="0" marL="457200" rtl="0" algn="l">
+            <a:pPr indent="-289242" lvl="0" marL="457200" rtl="0" algn="l">
+              <a:lnSpc>
+                <a:spcPct val="105000"/>
+              </a:lnSpc>
               <a:spcBef>
                 <a:spcPts val="1200"/>
               </a:spcBef>
               <a:spcAft>
                 <a:spcPts val="0"/>
               </a:spcAft>
-              <a:buSzPct val="100000"/>
+              <a:buSzPts val="955"/>
               <a:buAutoNum type="arabicPeriod"/>
             </a:pPr>
             <a:r>
-              <a:rPr lang="en"/>
-              <a:t>Form queries (what to look for)</a:t>
-            </a:r>
-            <a:endParaRPr/>
+              <a:rPr lang="en" sz="955"/>
+              <a:t>Form </a:t>
+            </a:r>
+            <a:r>
+              <a:rPr i="1" lang="en" sz="955"/>
+              <a:t>queries</a:t>
+            </a:r>
+            <a:r>
+              <a:rPr lang="en" sz="955"/>
+              <a:t> (what to look for)</a:t>
+            </a:r>
+            <a:endParaRPr sz="955"/>
           </a:p>
           <a:p>
-            <a:pPr indent="-282892" lvl="0" marL="457200" rtl="0" algn="l">
-              <a:spcBef>
-                <a:spcPts val="0"/>
-              </a:spcBef>
-              <a:spcAft>
-                <a:spcPts val="0"/>
-              </a:spcAft>
-              <a:buSzPct val="100000"/>
+            <a:pPr indent="-289242" lvl="0" marL="457200" rtl="0" algn="l">
+              <a:lnSpc>
+                <a:spcPct val="105000"/>
+              </a:lnSpc>
+              <a:spcBef>
+                <a:spcPts val="0"/>
+              </a:spcBef>
+              <a:spcAft>
+                <a:spcPts val="0"/>
+              </a:spcAft>
+              <a:buSzPts val="955"/>
               <a:buAutoNum type="arabicPeriod"/>
             </a:pPr>
             <a:r>
-              <a:rPr lang="en"/>
-              <a:t>Form keys (how to match, advertise relevance)</a:t>
-            </a:r>
-            <a:endParaRPr/>
+              <a:rPr lang="en" sz="955"/>
+              <a:t>Form </a:t>
+            </a:r>
+            <a:r>
+              <a:rPr i="1" lang="en" sz="955"/>
+              <a:t>keys</a:t>
+            </a:r>
+            <a:r>
+              <a:rPr lang="en" sz="955"/>
+              <a:t> (how to match, advertise relevance)</a:t>
+            </a:r>
+            <a:endParaRPr sz="955"/>
           </a:p>
           <a:p>
-            <a:pPr indent="-282892" lvl="0" marL="457200" rtl="0" algn="l">
-              <a:spcBef>
-                <a:spcPts val="0"/>
-              </a:spcBef>
-              <a:spcAft>
-                <a:spcPts val="0"/>
-              </a:spcAft>
-              <a:buSzPct val="100000"/>
+            <a:pPr indent="-289242" lvl="0" marL="457200" rtl="0" algn="l">
+              <a:lnSpc>
+                <a:spcPct val="105000"/>
+              </a:lnSpc>
+              <a:spcBef>
+                <a:spcPts val="0"/>
+              </a:spcBef>
+              <a:spcAft>
+                <a:spcPts val="0"/>
+              </a:spcAft>
+              <a:buSzPts val="955"/>
               <a:buAutoNum type="arabicPeriod"/>
             </a:pPr>
             <a:r>
-              <a:rPr lang="en"/>
-              <a:t>Form values (what information to extract from those tokens)</a:t>
-            </a:r>
-            <a:endParaRPr/>
+              <a:rPr lang="en" sz="955"/>
+              <a:t>Form </a:t>
+            </a:r>
+            <a:r>
+              <a:rPr i="1" lang="en" sz="955"/>
+              <a:t>values</a:t>
+            </a:r>
+            <a:r>
+              <a:rPr lang="en" sz="955"/>
+              <a:t> (what information to extract from those tokens)</a:t>
+            </a:r>
+            <a:endParaRPr sz="955"/>
           </a:p>
         </p:txBody>
       </p:sp>
       <p:pic>
         <p:nvPicPr>
-          <p:cNvPr descr="{&quot;backgroundColor&quot;:&quot;#FFFFFF&quot;,&quot;type&quot;:&quot;gather*&quot;,&quot;code&quot;:&quot;\\begin{gather*}\n{1.\\,\\text{Map}\\;\\text{query}\\;\\text{token}\\;\\text{embedding}\\;\\text{to}\\;\\text{a}\\;\\text{query}\\;\\text{vector}}\\\\\n{q=W_{Q}u}\\\\\n{\\text{2.}\\;\\text{Map}\\;\\text{sentence}\\;\\text{tokens}\\;\\text{to}\\;\\text{key}\\;\\text{and}\\;\\text{value}\\;\\text{vectors}}\\\\\n{k_{i}=W_{K}x_{i}}\\\\\n{v_{i}=W_{V}x_{i}}\\\\\n{3.\\,\\text{Calculate}\\;\\text{match}\\;\\text{scores,}\\;\\text{i.e.,}\\;\\text{how}\\;\\text{relevant}\\;\\text{is}\\;\\text{each}\\;\\text{token}\\;\\text{to}\\;\\text{the}\\;\\text{query?}}\\\\\n{s_{i}=q^{T}k_{i}}\\\\\n{\\text{4.}\\;\\text{Apply}\\;\\text{softmax}\\,\\text{to}\\;\\text{normalize}\\,\\text{scores}}\\\\\n{\\alpha_{i}=\\frac{\\exp\\left(s_{i}\\right)}{\\sum_{j=1}^{L}\\exp\\left(s_{j}\\right)},\\,L:\\text{number}\\;\\text{of}\\;\\text{tokens}}\\\\\n{\\text{Take}\\;\\text{linear}\\;\\text{combination}\\;\\text{of}\\;\\text{the}\\;\\text{values.}\\;\\text{}}\\\\\n{h=v_{i}\\alpha_{i}}\\\\\n{\\text{This}\\;\\text{is}\\;\\text{the}\\;\\text{contribution}\\;\\text{of}\\;\\text{all}\\;\\text{the}\\;\\text{tokens}\\;\\text{to}\\;\\text{the}\\;\\text{query}\\;\\text{u}}\t\n\\end{gather*}&quot;,&quot;backgroundColorModified&quot;:false,&quot;aid&quot;:null,&quot;id&quot;:&quot;2&quot;,&quot;font&quot;:{&quot;family&quot;:&quot;Arial&quot;,&quot;color&quot;:&quot;#000000&quot;,&quot;size&quot;:14},&quot;ts&quot;:1771421645638,&quot;cs&quot;:&quot;uH8d5+4RFeiVg5K9fYmlEA==&quot;,&quot;size&quot;:{&quot;width&quot;:672.5,&quot;height&quot;:377}}" id="112" name="Google Shape;112;p19"/>
+          <p:cNvPr descr="{&quot;backgroundColor&quot;:&quot;#FFFFFF&quot;,&quot;type&quot;:&quot;gather*&quot;,&quot;code&quot;:&quot;\\begin{gather*}\n{1.\\,\\text{Map}\\;\\text{query}\\;\\text{token}\\;\\text{embedding}\\;\\text{to}\\;\\text{a}\\;\\text{query}\\;\\text{vector}}\\\\\n{q=W_{Q}u}\\\\\n{\\text{2.}\\;\\text{Map}\\;\\text{sentence}\\;\\text{tokens}\\;\\text{to}\\;\\text{key}\\;\\text{and}\\;\\text{value}\\;\\text{vectors}}\\\\\n{k_{i}=W_{K}x_{i}}\\\\\n{v_{i}=W_{V}x_{i}}\\\\\n{3.\\,\\text{Calculate}\\;\\text{match}\\;\\text{scores,}\\;\\text{i.e.,}\\;\\text{how}\\;\\text{relevant}\\;\\text{is}\\;\\text{each}\\;\\text{token}\\;\\text{to}\\;\\text{the}\\;\\text{query?}}\\\\\n{s_{i}=q^{T}k_{i}}\\\\\n{\\text{4.}\\;\\text{Apply}\\;\\text{softmax}\\,\\text{to}\\;\\text{normalize}\\,\\text{scores}}\\\\\n{\\alpha_{i}=\\frac{\\exp\\left(s_{i}\\right)}{\\sum_{j=1}^{L}\\exp\\left(s_{j}\\right)},\\,L:\\text{number}\\;\\text{of}\\;\\text{tokens}}\\\\\n{\\text{Take}\\;\\text{linear}\\;\\text{combination}\\;\\text{of}\\;\\text{the}\\;\\text{values.}\\;\\text{}}\\\\\n{h=v_{i}\\alpha_{i}}\\\\\n{\\text{This}\\;\\text{is}\\;\\text{the}\\;\\text{contribution}\\;\\text{of}\\;\\text{all}\\;\\text{the}\\;\\text{tokens}\\;\\text{to}\\;\\text{the}\\;\\text{query}\\;\\text{u}}\t\n\\end{gather*}&quot;,&quot;backgroundColorModified&quot;:false,&quot;aid&quot;:null,&quot;id&quot;:&quot;2&quot;,&quot;font&quot;:{&quot;family&quot;:&quot;Arial&quot;,&quot;color&quot;:&quot;#000000&quot;,&quot;size&quot;:14},&quot;ts&quot;:1771421645638,&quot;cs&quot;:&quot;uH8d5+4RFeiVg5K9fYmlEA==&quot;,&quot;size&quot;:{&quot;width&quot;:672.5,&quot;height&quot;:377}}" id="106" name="Google Shape;106;p18"/>
           <p:cNvPicPr preferRelativeResize="0"/>
           <p:nvPr/>
         </p:nvPicPr>
@@ -14170,6 +14768,99 @@
           <a:xfrm>
             <a:off x="2968524" y="1286250"/>
             <a:ext cx="6405563" cy="3590925"/>
+          </a:xfrm>
+          <a:prstGeom prst="rect">
+            <a:avLst/>
+          </a:prstGeom>
+          <a:noFill/>
+          <a:ln>
+            <a:noFill/>
+          </a:ln>
+        </p:spPr>
+      </p:pic>
+    </p:spTree>
+  </p:cSld>
+  <p:clrMapOvr>
+    <a:masterClrMapping/>
+  </p:clrMapOvr>
+</p:sld>
+</file>
+
+<file path=ppt/slides/slide7.xml><?xml version="1.0" encoding="utf-8"?>
+<p:sld xmlns:a="http://schemas.openxmlformats.org/drawingml/2006/main" xmlns:r="http://schemas.openxmlformats.org/officeDocument/2006/relationships" xmlns:mc="http://schemas.openxmlformats.org/markup-compatibility/2006" xmlns:mv="urn:schemas-microsoft-com:mac:vml" xmlns:p="http://schemas.openxmlformats.org/presentationml/2006/main" xmlns:c="http://schemas.openxmlformats.org/drawingml/2006/chart" xmlns:dgm="http://schemas.openxmlformats.org/drawingml/2006/diagram" xmlns:o="urn:schemas-microsoft-com:office:office" xmlns:v="urn:schemas-microsoft-com:vml" xmlns:pvml="urn:schemas-microsoft-com:office:powerpoint" xmlns:com="http://schemas.openxmlformats.org/drawingml/2006/compatibility" xmlns:p14="http://schemas.microsoft.com/office/powerpoint/2010/main" xmlns:p15="http://schemas.microsoft.com/office/powerpoint/2012/main" xmlns:ahyp="http://schemas.microsoft.com/office/drawing/2018/hyperlinkcolor">
+  <p:cSld>
+    <p:spTree>
+      <p:nvGrpSpPr>
+        <p:cNvPr id="110" name="Shape 110"/>
+        <p:cNvGrpSpPr/>
+        <p:nvPr/>
+      </p:nvGrpSpPr>
+      <p:grpSpPr>
+        <a:xfrm>
+          <a:off x="0" y="0"/>
+          <a:ext cx="0" cy="0"/>
+          <a:chOff x="0" y="0"/>
+          <a:chExt cx="0" cy="0"/>
+        </a:xfrm>
+      </p:grpSpPr>
+      <p:sp>
+        <p:nvSpPr>
+          <p:cNvPr id="111" name="Google Shape;111;p19"/>
+          <p:cNvSpPr txBox="1"/>
+          <p:nvPr>
+            <p:ph type="title"/>
+          </p:nvPr>
+        </p:nvSpPr>
+        <p:spPr>
+          <a:xfrm>
+            <a:off x="311700" y="445025"/>
+            <a:ext cx="8520600" cy="572700"/>
+          </a:xfrm>
+          <a:prstGeom prst="rect">
+            <a:avLst/>
+          </a:prstGeom>
+        </p:spPr>
+        <p:txBody>
+          <a:bodyPr anchorCtr="0" anchor="t" bIns="91425" lIns="91425" spcFirstLastPara="1" rIns="91425" wrap="square" tIns="91425">
+            <a:normAutofit fontScale="90000"/>
+          </a:bodyPr>
+          <a:lstStyle/>
+          <a:p>
+            <a:pPr indent="0" lvl="0" marL="0" rtl="0" algn="l">
+              <a:spcBef>
+                <a:spcPts val="0"/>
+              </a:spcBef>
+              <a:spcAft>
+                <a:spcPts val="0"/>
+              </a:spcAft>
+              <a:buNone/>
+            </a:pPr>
+            <a:r>
+              <a:rPr lang="en"/>
+              <a:t>Self-Attention</a:t>
+            </a:r>
+            <a:endParaRPr/>
+          </a:p>
+        </p:txBody>
+      </p:sp>
+      <p:pic>
+        <p:nvPicPr>
+          <p:cNvPr descr="{&quot;id&quot;:&quot;2&quot;,&quot;font&quot;:{&quot;size&quot;:14,&quot;color&quot;:&quot;#000000&quot;,&quot;family&quot;:&quot;Arial&quot;},&quot;backgroundColorModified&quot;:false,&quot;type&quot;:&quot;gather*&quot;,&quot;backgroundColor&quot;:&quot;#FFFFFF&quot;,&quot;code&quot;:&quot;\\begin{gather*}\n{\\text{For}\\;\\text{an}\\;\\text{entire}\\;\\text{sequence}\\;\\text{X}\\in\\,\\Re^{t\\,\\times d}}\\\\\n{Q=XW_{Q},\\,K=XW_{K},\\,V=XW_{V}}\\\\\n{W_{Q},\\,W_{K}\\,\\text{are}\\;\\text{d}\\times d_{k}\\,\\text{matrices},\\,W_{V}\\,\\text{is}\\;d\\times d_{v}\\,\\text{matrix}}\\\\\n{\\text{Attn(}Q,K\\text{)=Softmax(}\\frac{QK^{T}}{{\\sqrt[]{d_{k}}}}\\text{)}}\\\\\n{\\text{division}\\;\\text{by}\\;{\\sqrt[]{d_{k}\\,}}\\,\\text{normalizes}\\;\\text{the}\\;\\text{dot}\\;\\text{product}}\\\\\n{\\text{The}\\;\\text{attention}\\;\\text{matrix}\\;\\text{(}t\\times t\\text{)}\\;\\text{encodes}\\;\\text{relevance}\\;\\text{o}\\text{f}\\;\\text{each}}\\\\\n{\\text{token}\\;\\text{in}\\;\\text{the}\\;\\text{sentence}\\;\\text{to}\\;\\text{all}\\;\\text{other}\\;\\text{tokens,}\\;\\text{including}\\;\\text{itself}}\\\\\n{\\text{Now}\\;\\text{I}\\;\\text{can}\\;\\text{obtain}\\;\\text{contextualized}\\;\\text{embedding}\\;\\text{for}\\;\\text{each}\\;\\text{token}}\\\\\n{E\\,=\\,Attn\\left(Q,K\\right)V}\\\\\n{E\\,\\text{is}\\;t\\times d_{v}\\,\\text{matrix}}\t\n\\end{gather*}&quot;,&quot;aid&quot;:null,&quot;ts&quot;:1772991734831,&quot;cs&quot;:&quot;VzxKXxqJ/qT+Fw9NPDcKkA==&quot;,&quot;size&quot;:{&quot;width&quot;:556,&quot;height&quot;:321.5}}" id="112" name="Google Shape;112;p19"/>
+          <p:cNvPicPr preferRelativeResize="0"/>
+          <p:nvPr/>
+        </p:nvPicPr>
+        <p:blipFill>
+          <a:blip r:embed="rId3">
+            <a:alphaModFix/>
+          </a:blip>
+          <a:stretch>
+            <a:fillRect/>
+          </a:stretch>
+        </p:blipFill>
+        <p:spPr>
+          <a:xfrm>
+            <a:off x="1021359" y="1299270"/>
+            <a:ext cx="5295900" cy="3062288"/>
           </a:xfrm>
           <a:prstGeom prst="rect">
             <a:avLst/>
@@ -14239,7 +14930,7 @@
             </a:pPr>
             <a:r>
               <a:rPr lang="en"/>
-              <a:t>Self-Attention</a:t>
+              <a:t>Self Attention</a:t>
             </a:r>
             <a:endParaRPr/>
           </a:p>
@@ -14247,7 +14938,7 @@
       </p:sp>
       <p:pic>
         <p:nvPicPr>
-          <p:cNvPr descr="{&quot;id&quot;:&quot;2&quot;,&quot;font&quot;:{&quot;size&quot;:14,&quot;color&quot;:&quot;#000000&quot;,&quot;family&quot;:&quot;Arial&quot;},&quot;backgroundColorModified&quot;:false,&quot;type&quot;:&quot;gather*&quot;,&quot;backgroundColor&quot;:&quot;#FFFFFF&quot;,&quot;code&quot;:&quot;\\begin{gather*}\n{\\text{For}\\;\\text{an}\\;\\text{entire}\\;\\text{sequence}\\;\\text{X}\\in\\,\\Re^{t\\,\\times d}}\\\\\n{Q=XW_{Q},\\,K=XW_{K},\\,V=XW_{V}}\\\\\n{W_{Q},\\,W_{K}\\,\\text{are}\\;\\text{d}\\times d_{k}\\,\\text{matrices},\\,W_{V}\\,\\text{is}\\;d\\times d_{v}\\,\\text{matrix}}\\\\\n{\\text{Attn(}Q,K\\text{)=Softmax(}\\frac{QK^{T}}{{\\sqrt[]{d_{k}}}}\\text{)}}\\\\\n{\\text{division}\\;\\text{by}\\;{\\sqrt[]{d_{k}\\,}}\\,\\text{normalizes}\\;\\text{the}\\;\\text{dot}\\;\\text{product}}\\\\\n{\\text{The}\\;\\text{attention}\\;\\text{matrix}\\;\\text{(}t\\times t\\text{)}\\;\\text{encodes}\\;\\text{relevance}\\;\\text{o}\\text{f}\\;\\text{each}}\\\\\n{\\text{token}\\;\\text{in}\\;\\text{the}\\;\\text{sentence}\\;\\text{to}\\;\\text{all}\\;\\text{other}\\;\\text{tokens,}\\;\\text{including}\\;\\text{itself}}\\\\\n{\\text{Now}\\;\\text{I}\\;\\text{can}\\;\\text{obtain}\\;\\text{contextualized}\\;\\text{embedding}\\;\\text{for}\\;\\text{each}\\;\\text{token}}\\\\\n{E\\,=\\,Attn\\left(Q,K\\right)V}\\\\\n{E\\,\\text{is}\\;t\\times d_{v}\\,\\text{matrix}}\t\n\\end{gather*}&quot;,&quot;aid&quot;:null,&quot;ts&quot;:1772991734831,&quot;cs&quot;:&quot;VzxKXxqJ/qT+Fw9NPDcKkA==&quot;,&quot;size&quot;:{&quot;width&quot;:556,&quot;height&quot;:321.5}}" id="118" name="Google Shape;118;p20"/>
+          <p:cNvPr id="118" name="Google Shape;118;p20"/>
           <p:cNvPicPr preferRelativeResize="0"/>
           <p:nvPr/>
         </p:nvPicPr>
@@ -14261,8 +14952,8 @@
         </p:blipFill>
         <p:spPr>
           <a:xfrm>
-            <a:off x="1021359" y="1299270"/>
-            <a:ext cx="5295900" cy="3062288"/>
+            <a:off x="152400" y="1170125"/>
+            <a:ext cx="6286120" cy="3820975"/>
           </a:xfrm>
           <a:prstGeom prst="rect">
             <a:avLst/>

</xml_diff>